<commit_message>
Modificacion final de archivos
</commit_message>
<xml_diff>
--- a/Fase 2/Evidencias Proyecto/Presentacion Proyecto.pptx
+++ b/Fase 2/Evidencias Proyecto/Presentacion Proyecto.pptx
@@ -812,7 +812,7 @@
   <p:cSld>
     <p:spTree>
       <p:nvGrpSpPr>
-        <p:cNvPr id="163" name="Shape 163"/>
+        <p:cNvPr id="202" name="Shape 202"/>
         <p:cNvGrpSpPr/>
         <p:nvPr/>
       </p:nvGrpSpPr>
@@ -826,7 +826,7 @@
       </p:grpSpPr>
       <p:sp>
         <p:nvSpPr>
-          <p:cNvPr id="164" name="Google Shape;164;g365e4a1968e_0_37:notes"/>
+          <p:cNvPr id="203" name="Google Shape;203;g365e4a1968e_0_37:notes"/>
           <p:cNvSpPr/>
           <p:nvPr>
             <p:ph idx="2" type="sldImg"/>
@@ -861,7 +861,7 @@
       </p:sp>
       <p:sp>
         <p:nvSpPr>
-          <p:cNvPr id="165" name="Google Shape;165;g365e4a1968e_0_37:notes"/>
+          <p:cNvPr id="204" name="Google Shape;204;g365e4a1968e_0_37:notes"/>
           <p:cNvSpPr txBox="1"/>
           <p:nvPr>
             <p:ph idx="1" type="body"/>
@@ -911,7 +911,7 @@
   <p:cSld>
     <p:spTree>
       <p:nvGrpSpPr>
-        <p:cNvPr id="170" name="Shape 170"/>
+        <p:cNvPr id="209" name="Shape 209"/>
         <p:cNvGrpSpPr/>
         <p:nvPr/>
       </p:nvGrpSpPr>
@@ -925,7 +925,7 @@
       </p:grpSpPr>
       <p:sp>
         <p:nvSpPr>
-          <p:cNvPr id="171" name="Google Shape;171;g365e4a1968e_0_42:notes"/>
+          <p:cNvPr id="210" name="Google Shape;210;g365e4a1968e_0_42:notes"/>
           <p:cNvSpPr/>
           <p:nvPr>
             <p:ph idx="2" type="sldImg"/>
@@ -960,7 +960,7 @@
       </p:sp>
       <p:sp>
         <p:nvSpPr>
-          <p:cNvPr id="172" name="Google Shape;172;g365e4a1968e_0_42:notes"/>
+          <p:cNvPr id="211" name="Google Shape;211;g365e4a1968e_0_42:notes"/>
           <p:cNvSpPr txBox="1"/>
           <p:nvPr>
             <p:ph idx="1" type="body"/>
@@ -1010,7 +1010,7 @@
   <p:cSld>
     <p:spTree>
       <p:nvGrpSpPr>
-        <p:cNvPr id="178" name="Shape 178"/>
+        <p:cNvPr id="221" name="Shape 221"/>
         <p:cNvGrpSpPr/>
         <p:nvPr/>
       </p:nvGrpSpPr>
@@ -1024,7 +1024,7 @@
       </p:grpSpPr>
       <p:sp>
         <p:nvSpPr>
-          <p:cNvPr id="179" name="Google Shape;179;g365e4a1968e_0_47:notes"/>
+          <p:cNvPr id="222" name="Google Shape;222;g365e4a1968e_0_47:notes"/>
           <p:cNvSpPr/>
           <p:nvPr>
             <p:ph idx="2" type="sldImg"/>
@@ -1059,7 +1059,7 @@
       </p:sp>
       <p:sp>
         <p:nvSpPr>
-          <p:cNvPr id="180" name="Google Shape;180;g365e4a1968e_0_47:notes"/>
+          <p:cNvPr id="223" name="Google Shape;223;g365e4a1968e_0_47:notes"/>
           <p:cNvSpPr txBox="1"/>
           <p:nvPr>
             <p:ph idx="1" type="body"/>
@@ -1109,7 +1109,7 @@
   <p:cSld>
     <p:spTree>
       <p:nvGrpSpPr>
-        <p:cNvPr id="185" name="Shape 185"/>
+        <p:cNvPr id="228" name="Shape 228"/>
         <p:cNvGrpSpPr/>
         <p:nvPr/>
       </p:nvGrpSpPr>
@@ -1123,7 +1123,7 @@
       </p:grpSpPr>
       <p:sp>
         <p:nvSpPr>
-          <p:cNvPr id="186" name="Google Shape;186;g367a29ea15a_0_49:notes"/>
+          <p:cNvPr id="229" name="Google Shape;229;g367a29ea15a_0_49:notes"/>
           <p:cNvSpPr/>
           <p:nvPr>
             <p:ph idx="2" type="sldImg"/>
@@ -1158,7 +1158,7 @@
       </p:sp>
       <p:sp>
         <p:nvSpPr>
-          <p:cNvPr id="187" name="Google Shape;187;g367a29ea15a_0_49:notes"/>
+          <p:cNvPr id="230" name="Google Shape;230;g367a29ea15a_0_49:notes"/>
           <p:cNvSpPr txBox="1"/>
           <p:nvPr>
             <p:ph idx="1" type="body"/>
@@ -1208,7 +1208,7 @@
   <p:cSld>
     <p:spTree>
       <p:nvGrpSpPr>
-        <p:cNvPr id="192" name="Shape 192"/>
+        <p:cNvPr id="235" name="Shape 235"/>
         <p:cNvGrpSpPr/>
         <p:nvPr/>
       </p:nvGrpSpPr>
@@ -1222,7 +1222,7 @@
       </p:grpSpPr>
       <p:sp>
         <p:nvSpPr>
-          <p:cNvPr id="193" name="Google Shape;193;g367a29ea15a_0_58:notes"/>
+          <p:cNvPr id="236" name="Google Shape;236;g33d64727d8a_0_2:notes"/>
           <p:cNvSpPr/>
           <p:nvPr>
             <p:ph idx="2" type="sldImg"/>
@@ -1257,7 +1257,7 @@
       </p:sp>
       <p:sp>
         <p:nvSpPr>
-          <p:cNvPr id="194" name="Google Shape;194;g367a29ea15a_0_58:notes"/>
+          <p:cNvPr id="237" name="Google Shape;237;g33d64727d8a_0_2:notes"/>
           <p:cNvSpPr txBox="1"/>
           <p:nvPr>
             <p:ph idx="1" type="body"/>
@@ -1703,7 +1703,7 @@
   <p:cSld>
     <p:spTree>
       <p:nvGrpSpPr>
-        <p:cNvPr id="131" name="Shape 131"/>
+        <p:cNvPr id="138" name="Shape 138"/>
         <p:cNvGrpSpPr/>
         <p:nvPr/>
       </p:nvGrpSpPr>
@@ -1717,7 +1717,7 @@
       </p:grpSpPr>
       <p:sp>
         <p:nvSpPr>
-          <p:cNvPr id="132" name="Google Shape;132;g367a29ea15a_0_27:notes"/>
+          <p:cNvPr id="139" name="Google Shape;139;g367a29ea15a_0_27:notes"/>
           <p:cNvSpPr/>
           <p:nvPr>
             <p:ph idx="2" type="sldImg"/>
@@ -1752,7 +1752,7 @@
       </p:sp>
       <p:sp>
         <p:nvSpPr>
-          <p:cNvPr id="133" name="Google Shape;133;g367a29ea15a_0_27:notes"/>
+          <p:cNvPr id="140" name="Google Shape;140;g367a29ea15a_0_27:notes"/>
           <p:cNvSpPr txBox="1"/>
           <p:nvPr>
             <p:ph idx="1" type="body"/>
@@ -1802,7 +1802,7 @@
   <p:cSld>
     <p:spTree>
       <p:nvGrpSpPr>
-        <p:cNvPr id="141" name="Shape 141"/>
+        <p:cNvPr id="148" name="Shape 148"/>
         <p:cNvGrpSpPr/>
         <p:nvPr/>
       </p:nvGrpSpPr>
@@ -1816,7 +1816,7 @@
       </p:grpSpPr>
       <p:sp>
         <p:nvSpPr>
-          <p:cNvPr id="142" name="Google Shape;142;g365e4a1968e_0_27:notes"/>
+          <p:cNvPr id="149" name="Google Shape;149;g365e4a1968e_0_27:notes"/>
           <p:cNvSpPr/>
           <p:nvPr>
             <p:ph idx="2" type="sldImg"/>
@@ -1851,7 +1851,7 @@
       </p:sp>
       <p:sp>
         <p:nvSpPr>
-          <p:cNvPr id="143" name="Google Shape;143;g365e4a1968e_0_27:notes"/>
+          <p:cNvPr id="150" name="Google Shape;150;g365e4a1968e_0_27:notes"/>
           <p:cNvSpPr txBox="1"/>
           <p:nvPr>
             <p:ph idx="1" type="body"/>
@@ -1901,7 +1901,7 @@
   <p:cSld>
     <p:spTree>
       <p:nvGrpSpPr>
-        <p:cNvPr id="149" name="Shape 149"/>
+        <p:cNvPr id="156" name="Shape 156"/>
         <p:cNvGrpSpPr/>
         <p:nvPr/>
       </p:nvGrpSpPr>
@@ -1915,7 +1915,7 @@
       </p:grpSpPr>
       <p:sp>
         <p:nvSpPr>
-          <p:cNvPr id="150" name="Google Shape;150;g36717ff27b5_2_5:notes"/>
+          <p:cNvPr id="157" name="Google Shape;157;g36717ff27b5_2_5:notes"/>
           <p:cNvSpPr/>
           <p:nvPr>
             <p:ph idx="2" type="sldImg"/>
@@ -1950,7 +1950,7 @@
       </p:sp>
       <p:sp>
         <p:nvSpPr>
-          <p:cNvPr id="151" name="Google Shape;151;g36717ff27b5_2_5:notes"/>
+          <p:cNvPr id="158" name="Google Shape;158;g36717ff27b5_2_5:notes"/>
           <p:cNvSpPr txBox="1"/>
           <p:nvPr>
             <p:ph idx="1" type="body"/>
@@ -2000,7 +2000,7 @@
   <p:cSld>
     <p:spTree>
       <p:nvGrpSpPr>
-        <p:cNvPr id="156" name="Shape 156"/>
+        <p:cNvPr id="164" name="Shape 164"/>
         <p:cNvGrpSpPr/>
         <p:nvPr/>
       </p:nvGrpSpPr>
@@ -2014,7 +2014,7 @@
       </p:grpSpPr>
       <p:sp>
         <p:nvSpPr>
-          <p:cNvPr id="157" name="Google Shape;157;g365e4a1968e_0_32:notes"/>
+          <p:cNvPr id="165" name="Google Shape;165;g365e4a1968e_0_32:notes"/>
           <p:cNvSpPr/>
           <p:nvPr>
             <p:ph idx="2" type="sldImg"/>
@@ -2049,7 +2049,7 @@
       </p:sp>
       <p:sp>
         <p:nvSpPr>
-          <p:cNvPr id="158" name="Google Shape;158;g365e4a1968e_0_32:notes"/>
+          <p:cNvPr id="166" name="Google Shape;166;g365e4a1968e_0_32:notes"/>
           <p:cNvSpPr txBox="1"/>
           <p:nvPr>
             <p:ph idx="1" type="body"/>
@@ -8001,6 +8001,18 @@
     <p:sldLayoutId id="2147483657" r:id="rId10"/>
     <p:sldLayoutId id="2147483658" r:id="rId11"/>
   </p:sldLayoutIdLst>
+  <mc:AlternateContent>
+    <mc:Choice Requires="p14">
+      <p:transition spd="slow" p14:dur="1000">
+        <p:fade thruBlk="1"/>
+      </p:transition>
+    </mc:Choice>
+    <mc:Fallback>
+      <p:transition spd="slow">
+        <p:fade/>
+      </p:transition>
+    </mc:Fallback>
+  </mc:AlternateContent>
   <p:hf dt="0" ftr="0" hdr="0" sldNum="0"/>
   <p:txStyles>
     <p:titleStyle>
@@ -8818,7 +8830,7 @@
   <p:cSld>
     <p:spTree>
       <p:nvGrpSpPr>
-        <p:cNvPr id="166" name="Shape 166"/>
+        <p:cNvPr id="205" name="Shape 205"/>
         <p:cNvGrpSpPr/>
         <p:nvPr/>
       </p:nvGrpSpPr>
@@ -8832,7 +8844,7 @@
       </p:grpSpPr>
       <p:sp>
         <p:nvSpPr>
-          <p:cNvPr id="167" name="Google Shape;167;p22"/>
+          <p:cNvPr id="206" name="Google Shape;206;p22"/>
           <p:cNvSpPr txBox="1"/>
           <p:nvPr>
             <p:ph type="title"/>
@@ -8840,7 +8852,7 @@
         </p:nvSpPr>
         <p:spPr>
           <a:xfrm>
-            <a:off x="262625" y="177550"/>
+            <a:off x="183650" y="88775"/>
             <a:ext cx="8520600" cy="607800"/>
           </a:xfrm>
           <a:prstGeom prst="rect">
@@ -8872,7 +8884,7 @@
       </p:sp>
       <p:pic>
         <p:nvPicPr>
-          <p:cNvPr descr="EscuelaIT Duoc UC - Escuela de Informática y Telecomunicaciones Duoc UC - Duoc  UC | LinkedIn" id="168" name="Google Shape;168;p22"/>
+          <p:cNvPr descr="EscuelaIT Duoc UC - Escuela de Informática y Telecomunicaciones Duoc UC - Duoc  UC | LinkedIn" id="207" name="Google Shape;207;p22"/>
           <p:cNvPicPr preferRelativeResize="0"/>
           <p:nvPr/>
         </p:nvPicPr>
@@ -8899,22 +8911,21 @@
       </p:pic>
       <p:pic>
         <p:nvPicPr>
-          <p:cNvPr id="169" name="Google Shape;169;p22"/>
+          <p:cNvPr id="208" name="Google Shape;208;p22" title="Modelo_Relacional_page-0001.jpg"/>
           <p:cNvPicPr preferRelativeResize="0"/>
           <p:nvPr/>
         </p:nvPicPr>
-        <p:blipFill>
+        <p:blipFill rotWithShape="1">
           <a:blip r:embed="rId4">
             <a:alphaModFix/>
           </a:blip>
-          <a:stretch>
-            <a:fillRect/>
-          </a:stretch>
+          <a:srcRect b="0" l="7364" r="0" t="4159"/>
+          <a:stretch/>
         </p:blipFill>
         <p:spPr>
           <a:xfrm>
-            <a:off x="1399475" y="831225"/>
-            <a:ext cx="6911027" cy="3820900"/>
+            <a:off x="607025" y="627475"/>
+            <a:ext cx="7929943" cy="4402476"/>
           </a:xfrm>
           <a:prstGeom prst="rect">
             <a:avLst/>
@@ -8944,7 +8955,7 @@
   <p:cSld>
     <p:spTree>
       <p:nvGrpSpPr>
-        <p:cNvPr id="173" name="Shape 173"/>
+        <p:cNvPr id="212" name="Shape 212"/>
         <p:cNvGrpSpPr/>
         <p:nvPr/>
       </p:nvGrpSpPr>
@@ -8958,7 +8969,7 @@
       </p:grpSpPr>
       <p:sp>
         <p:nvSpPr>
-          <p:cNvPr id="174" name="Google Shape;174;p23"/>
+          <p:cNvPr id="213" name="Google Shape;213;p23"/>
           <p:cNvSpPr txBox="1"/>
           <p:nvPr>
             <p:ph type="title"/>
@@ -8966,7 +8977,7 @@
         </p:nvSpPr>
         <p:spPr>
           <a:xfrm>
-            <a:off x="311700" y="410000"/>
+            <a:off x="193250" y="88775"/>
             <a:ext cx="5648700" cy="607800"/>
           </a:xfrm>
           <a:prstGeom prst="rect">
@@ -8998,7 +9009,7 @@
       </p:sp>
       <p:sp>
         <p:nvSpPr>
-          <p:cNvPr id="175" name="Google Shape;175;p23"/>
+          <p:cNvPr id="214" name="Google Shape;214;p23"/>
           <p:cNvSpPr txBox="1"/>
           <p:nvPr>
             <p:ph idx="1" type="body"/>
@@ -9006,7 +9017,7 @@
         </p:nvSpPr>
         <p:spPr>
           <a:xfrm>
-            <a:off x="311700" y="1229875"/>
+            <a:off x="311700" y="963325"/>
             <a:ext cx="8520600" cy="3339000"/>
           </a:xfrm>
           <a:prstGeom prst="rect">
@@ -9015,7 +9026,7 @@
         </p:spPr>
         <p:txBody>
           <a:bodyPr anchorCtr="0" anchor="t" bIns="91425" lIns="91425" spcFirstLastPara="1" rIns="91425" wrap="square" tIns="91425">
-            <a:normAutofit/>
+            <a:noAutofit/>
           </a:bodyPr>
           <a:lstStyle/>
           <a:p>
@@ -9029,98 +9040,308 @@
               <a:buNone/>
             </a:pPr>
             <a:r>
-              <a:t/>
+              <a:rPr lang="es" sz="1600">
+                <a:solidFill>
+                  <a:srgbClr val="000000"/>
+                </a:solidFill>
+              </a:rPr>
+              <a:t>Las principales herramientas empleadas en el desarrollo de </a:t>
             </a:r>
-            <a:endParaRPr/>
+            <a:r>
+              <a:rPr i="1" lang="es" sz="1600">
+                <a:solidFill>
+                  <a:srgbClr val="000000"/>
+                </a:solidFill>
+              </a:rPr>
+              <a:t>Panorama</a:t>
+            </a:r>
+            <a:r>
+              <a:rPr lang="es" sz="1600">
+                <a:solidFill>
+                  <a:srgbClr val="000000"/>
+                </a:solidFill>
+              </a:rPr>
+              <a:t> son:</a:t>
+            </a:r>
+            <a:endParaRPr sz="1600"/>
           </a:p>
           <a:p>
-            <a:pPr indent="0" lvl="0" marL="0" rtl="0" algn="l">
+            <a:pPr indent="-330200" lvl="0" marL="457200" rtl="0" algn="l">
               <a:spcBef>
                 <a:spcPts val="1200"/>
               </a:spcBef>
               <a:spcAft>
                 <a:spcPts val="0"/>
               </a:spcAft>
-              <a:buNone/>
-            </a:pPr>
-            <a:r>
-              <a:rPr lang="es"/>
-              <a:t>Las </a:t>
-            </a:r>
-            <a:r>
-              <a:rPr lang="es"/>
-              <a:t>tecnologías</a:t>
-            </a:r>
-            <a:r>
-              <a:rPr lang="es"/>
-              <a:t> </a:t>
-            </a:r>
-            <a:r>
-              <a:rPr lang="es"/>
-              <a:t>utilizados</a:t>
-            </a:r>
-            <a:r>
-              <a:rPr lang="es"/>
-              <a:t> son:</a:t>
-            </a:r>
-            <a:endParaRPr/>
-          </a:p>
-          <a:p>
-            <a:pPr indent="-342900" lvl="0" marL="457200" rtl="0" algn="l">
-              <a:spcBef>
-                <a:spcPts val="1200"/>
-              </a:spcBef>
-              <a:spcAft>
-                <a:spcPts val="0"/>
-              </a:spcAft>
-              <a:buSzPts val="1800"/>
+              <a:buSzPts val="1600"/>
               <a:buChar char="●"/>
             </a:pPr>
             <a:r>
-              <a:rPr lang="es"/>
-              <a:t>Elysia Js(Back-End)</a:t>
+              <a:rPr b="1" lang="es" sz="1600">
+                <a:solidFill>
+                  <a:srgbClr val="000000"/>
+                </a:solidFill>
+              </a:rPr>
+              <a:t>Backend:</a:t>
             </a:r>
-            <a:endParaRPr/>
+            <a:br>
+              <a:rPr b="1" lang="es" sz="1600">
+                <a:solidFill>
+                  <a:srgbClr val="000000"/>
+                </a:solidFill>
+              </a:rPr>
+            </a:br>
+            <a:r>
+              <a:rPr b="1" lang="es" sz="1600">
+                <a:solidFill>
+                  <a:srgbClr val="000000"/>
+                </a:solidFill>
+              </a:rPr>
+              <a:t>Elysia.js </a:t>
+            </a:r>
+            <a:r>
+              <a:rPr lang="es" sz="1600">
+                <a:solidFill>
+                  <a:srgbClr val="000000"/>
+                </a:solidFill>
+              </a:rPr>
+              <a:t>(framework web) + </a:t>
+            </a:r>
+            <a:r>
+              <a:rPr b="1" lang="es" sz="1600">
+                <a:solidFill>
+                  <a:srgbClr val="000000"/>
+                </a:solidFill>
+              </a:rPr>
+              <a:t>Bun</a:t>
+            </a:r>
+            <a:br>
+              <a:rPr lang="es" sz="1600">
+                <a:solidFill>
+                  <a:srgbClr val="000000"/>
+                </a:solidFill>
+              </a:rPr>
+            </a:br>
+            <a:r>
+              <a:rPr lang="es" sz="1600">
+                <a:solidFill>
+                  <a:srgbClr val="000000"/>
+                </a:solidFill>
+              </a:rPr>
+              <a:t>Validación con </a:t>
+            </a:r>
+            <a:r>
+              <a:rPr b="1" lang="es" sz="1600">
+                <a:solidFill>
+                  <a:srgbClr val="000000"/>
+                </a:solidFill>
+              </a:rPr>
+              <a:t>Zod</a:t>
+            </a:r>
+            <a:r>
+              <a:rPr lang="es" sz="1600">
+                <a:solidFill>
+                  <a:srgbClr val="000000"/>
+                </a:solidFill>
+              </a:rPr>
+              <a:t> y documentación con </a:t>
+            </a:r>
+            <a:r>
+              <a:rPr b="1" lang="es" sz="1600">
+                <a:solidFill>
+                  <a:srgbClr val="000000"/>
+                </a:solidFill>
+              </a:rPr>
+              <a:t>Swagger</a:t>
+            </a:r>
+            <a:br>
+              <a:rPr b="1" lang="es" sz="1600">
+                <a:solidFill>
+                  <a:srgbClr val="000000"/>
+                </a:solidFill>
+              </a:rPr>
+            </a:br>
+            <a:endParaRPr b="1" sz="1600">
+              <a:solidFill>
+                <a:srgbClr val="000000"/>
+              </a:solidFill>
+            </a:endParaRPr>
           </a:p>
           <a:p>
-            <a:pPr indent="-342900" lvl="0" marL="457200" rtl="0" algn="l">
-              <a:spcBef>
-                <a:spcPts val="0"/>
-              </a:spcBef>
-              <a:spcAft>
-                <a:spcPts val="0"/>
-              </a:spcAft>
-              <a:buSzPts val="1800"/>
+            <a:pPr indent="-330200" lvl="0" marL="457200" rtl="0" algn="l">
+              <a:spcBef>
+                <a:spcPts val="0"/>
+              </a:spcBef>
+              <a:spcAft>
+                <a:spcPts val="0"/>
+              </a:spcAft>
+              <a:buSzPts val="1600"/>
               <a:buChar char="●"/>
             </a:pPr>
             <a:r>
-              <a:rPr lang="es"/>
-              <a:t>Next Js(Front-End)</a:t>
+              <a:rPr b="1" lang="es" sz="1600">
+                <a:solidFill>
+                  <a:srgbClr val="000000"/>
+                </a:solidFill>
+              </a:rPr>
+              <a:t>Frontend:</a:t>
             </a:r>
-            <a:endParaRPr/>
+            <a:br>
+              <a:rPr b="1" lang="es" sz="1600">
+                <a:solidFill>
+                  <a:srgbClr val="000000"/>
+                </a:solidFill>
+              </a:rPr>
+            </a:br>
+            <a:r>
+              <a:rPr b="1" lang="es" sz="1600">
+                <a:solidFill>
+                  <a:srgbClr val="000000"/>
+                </a:solidFill>
+              </a:rPr>
+              <a:t>Next.js</a:t>
+            </a:r>
+            <a:r>
+              <a:rPr lang="es" sz="1600">
+                <a:solidFill>
+                  <a:srgbClr val="000000"/>
+                </a:solidFill>
+              </a:rPr>
+              <a:t> 15 con App Router y </a:t>
+            </a:r>
+            <a:r>
+              <a:rPr b="1" lang="es" sz="1600">
+                <a:solidFill>
+                  <a:srgbClr val="000000"/>
+                </a:solidFill>
+              </a:rPr>
+              <a:t>TypeScript</a:t>
+            </a:r>
+            <a:br>
+              <a:rPr b="1" lang="es" sz="1600">
+                <a:solidFill>
+                  <a:srgbClr val="000000"/>
+                </a:solidFill>
+              </a:rPr>
+            </a:br>
+            <a:r>
+              <a:rPr lang="es" sz="1600">
+                <a:solidFill>
+                  <a:srgbClr val="000000"/>
+                </a:solidFill>
+              </a:rPr>
+              <a:t>UI moderna con </a:t>
+            </a:r>
+            <a:r>
+              <a:rPr b="1" lang="es" sz="1600">
+                <a:solidFill>
+                  <a:srgbClr val="000000"/>
+                </a:solidFill>
+              </a:rPr>
+              <a:t>Tailwind CSS</a:t>
+            </a:r>
+            <a:r>
+              <a:rPr lang="es" sz="1600">
+                <a:solidFill>
+                  <a:srgbClr val="000000"/>
+                </a:solidFill>
+              </a:rPr>
+              <a:t>, </a:t>
+            </a:r>
+            <a:r>
+              <a:rPr b="1" lang="es" sz="1600">
+                <a:solidFill>
+                  <a:srgbClr val="000000"/>
+                </a:solidFill>
+              </a:rPr>
+              <a:t>Radix UI</a:t>
+            </a:r>
+            <a:r>
+              <a:rPr lang="es" sz="1600">
+                <a:solidFill>
+                  <a:srgbClr val="000000"/>
+                </a:solidFill>
+              </a:rPr>
+              <a:t> y </a:t>
+            </a:r>
+            <a:r>
+              <a:rPr b="1" lang="es" sz="1600">
+                <a:solidFill>
+                  <a:srgbClr val="000000"/>
+                </a:solidFill>
+              </a:rPr>
+              <a:t>shadcn/ui</a:t>
+            </a:r>
+            <a:br>
+              <a:rPr b="1" lang="es" sz="1600">
+                <a:solidFill>
+                  <a:srgbClr val="000000"/>
+                </a:solidFill>
+              </a:rPr>
+            </a:br>
+            <a:endParaRPr b="1" sz="1600">
+              <a:solidFill>
+                <a:srgbClr val="000000"/>
+              </a:solidFill>
+            </a:endParaRPr>
           </a:p>
           <a:p>
-            <a:pPr indent="-342900" lvl="0" marL="457200" rtl="0" algn="l">
-              <a:spcBef>
-                <a:spcPts val="0"/>
-              </a:spcBef>
-              <a:spcAft>
-                <a:spcPts val="0"/>
-              </a:spcAft>
-              <a:buSzPts val="1800"/>
+            <a:pPr indent="-330200" lvl="0" marL="457200" rtl="0" algn="l">
+              <a:spcBef>
+                <a:spcPts val="0"/>
+              </a:spcBef>
+              <a:spcAft>
+                <a:spcPts val="0"/>
+              </a:spcAft>
+              <a:buSzPts val="1600"/>
               <a:buChar char="●"/>
             </a:pPr>
             <a:r>
-              <a:rPr lang="es"/>
-              <a:t>Supabase(PostgresQL)</a:t>
+              <a:rPr b="1" lang="es" sz="1600">
+                <a:solidFill>
+                  <a:srgbClr val="000000"/>
+                </a:solidFill>
+              </a:rPr>
+              <a:t>Base de Datos:</a:t>
             </a:r>
-            <a:endParaRPr/>
+            <a:br>
+              <a:rPr b="1" lang="es" sz="1600">
+                <a:solidFill>
+                  <a:srgbClr val="000000"/>
+                </a:solidFill>
+              </a:rPr>
+            </a:br>
+            <a:r>
+              <a:rPr b="1" lang="es" sz="1600">
+                <a:solidFill>
+                  <a:srgbClr val="000000"/>
+                </a:solidFill>
+              </a:rPr>
+              <a:t>PostgreSQL</a:t>
+            </a:r>
+            <a:r>
+              <a:rPr lang="es" sz="1600">
+                <a:solidFill>
+                  <a:srgbClr val="000000"/>
+                </a:solidFill>
+              </a:rPr>
+              <a:t> alojada en Supabase, manejada con ORM </a:t>
+            </a:r>
+            <a:r>
+              <a:rPr b="1" lang="es" sz="1600">
+                <a:solidFill>
+                  <a:srgbClr val="000000"/>
+                </a:solidFill>
+              </a:rPr>
+              <a:t>Drizzle</a:t>
+            </a:r>
+            <a:endParaRPr sz="1600"/>
           </a:p>
         </p:txBody>
       </p:sp>
       <p:pic>
         <p:nvPicPr>
-          <p:cNvPr descr="EscuelaIT Duoc UC - Escuela de Informática y Telecomunicaciones Duoc UC - Duoc  UC | LinkedIn" id="176" name="Google Shape;176;p23"/>
+          <p:cNvPr descr="EscuelaIT Duoc UC - Escuela de Informática y Telecomunicaciones Duoc UC - Duoc  UC | LinkedIn" id="215" name="Google Shape;215;p23"/>
           <p:cNvPicPr preferRelativeResize="0"/>
           <p:nvPr/>
         </p:nvPicPr>
@@ -9147,7 +9368,7 @@
       </p:pic>
       <p:pic>
         <p:nvPicPr>
-          <p:cNvPr id="177" name="Google Shape;177;p23"/>
+          <p:cNvPr id="216" name="Google Shape;216;p23"/>
           <p:cNvPicPr preferRelativeResize="0"/>
           <p:nvPr/>
         </p:nvPicPr>
@@ -9161,21 +9382,127 @@
         </p:blipFill>
         <p:spPr>
           <a:xfrm>
-            <a:off x="5259350" y="739575"/>
-            <a:ext cx="3654525" cy="4109325"/>
+            <a:off x="6989850" y="1448700"/>
+            <a:ext cx="652800" cy="652800"/>
           </a:xfrm>
           <a:prstGeom prst="rect">
             <a:avLst/>
           </a:prstGeom>
           <a:noFill/>
-          <a:ln cap="flat" cmpd="sng" w="9525">
-            <a:solidFill>
-              <a:schemeClr val="dk2"/>
-            </a:solidFill>
-            <a:prstDash val="solid"/>
-            <a:round/>
-            <a:headEnd len="sm" w="sm" type="none"/>
-            <a:tailEnd len="sm" w="sm" type="none"/>
+          <a:ln>
+            <a:noFill/>
+          </a:ln>
+        </p:spPr>
+      </p:pic>
+      <p:pic>
+        <p:nvPicPr>
+          <p:cNvPr id="217" name="Google Shape;217;p23"/>
+          <p:cNvPicPr preferRelativeResize="0"/>
+          <p:nvPr/>
+        </p:nvPicPr>
+        <p:blipFill>
+          <a:blip r:embed="rId5">
+            <a:alphaModFix/>
+          </a:blip>
+          <a:stretch>
+            <a:fillRect/>
+          </a:stretch>
+        </p:blipFill>
+        <p:spPr>
+          <a:xfrm>
+            <a:off x="8031563" y="1489090"/>
+            <a:ext cx="652800" cy="572024"/>
+          </a:xfrm>
+          <a:prstGeom prst="rect">
+            <a:avLst/>
+          </a:prstGeom>
+          <a:noFill/>
+          <a:ln>
+            <a:noFill/>
+          </a:ln>
+        </p:spPr>
+      </p:pic>
+      <p:pic>
+        <p:nvPicPr>
+          <p:cNvPr id="218" name="Google Shape;218;p23"/>
+          <p:cNvPicPr preferRelativeResize="0"/>
+          <p:nvPr/>
+        </p:nvPicPr>
+        <p:blipFill>
+          <a:blip r:embed="rId6">
+            <a:alphaModFix/>
+          </a:blip>
+          <a:stretch>
+            <a:fillRect/>
+          </a:stretch>
+        </p:blipFill>
+        <p:spPr>
+          <a:xfrm>
+            <a:off x="6931825" y="2306413"/>
+            <a:ext cx="652800" cy="652800"/>
+          </a:xfrm>
+          <a:prstGeom prst="rect">
+            <a:avLst/>
+          </a:prstGeom>
+          <a:noFill/>
+          <a:ln>
+            <a:noFill/>
+          </a:ln>
+        </p:spPr>
+      </p:pic>
+      <p:pic>
+        <p:nvPicPr>
+          <p:cNvPr id="219" name="Google Shape;219;p23"/>
+          <p:cNvPicPr preferRelativeResize="0"/>
+          <p:nvPr/>
+        </p:nvPicPr>
+        <p:blipFill>
+          <a:blip r:embed="rId7">
+            <a:alphaModFix/>
+          </a:blip>
+          <a:stretch>
+            <a:fillRect/>
+          </a:stretch>
+        </p:blipFill>
+        <p:spPr>
+          <a:xfrm>
+            <a:off x="7949916" y="2306416"/>
+            <a:ext cx="652800" cy="652800"/>
+          </a:xfrm>
+          <a:prstGeom prst="rect">
+            <a:avLst/>
+          </a:prstGeom>
+          <a:noFill/>
+          <a:ln>
+            <a:noFill/>
+          </a:ln>
+        </p:spPr>
+      </p:pic>
+      <p:pic>
+        <p:nvPicPr>
+          <p:cNvPr id="220" name="Google Shape;220;p23"/>
+          <p:cNvPicPr preferRelativeResize="0"/>
+          <p:nvPr/>
+        </p:nvPicPr>
+        <p:blipFill>
+          <a:blip r:embed="rId8">
+            <a:alphaModFix/>
+          </a:blip>
+          <a:stretch>
+            <a:fillRect/>
+          </a:stretch>
+        </p:blipFill>
+        <p:spPr>
+          <a:xfrm>
+            <a:off x="7355125" y="3164150"/>
+            <a:ext cx="652800" cy="652800"/>
+          </a:xfrm>
+          <a:prstGeom prst="rect">
+            <a:avLst/>
+          </a:prstGeom>
+          <a:noFill/>
+          <a:ln>
+            <a:noFill/>
           </a:ln>
         </p:spPr>
       </p:pic>
@@ -9192,7 +9519,7 @@
   <p:cSld>
     <p:spTree>
       <p:nvGrpSpPr>
-        <p:cNvPr id="181" name="Shape 181"/>
+        <p:cNvPr id="224" name="Shape 224"/>
         <p:cNvGrpSpPr/>
         <p:nvPr/>
       </p:nvGrpSpPr>
@@ -9206,7 +9533,7 @@
       </p:grpSpPr>
       <p:sp>
         <p:nvSpPr>
-          <p:cNvPr id="182" name="Google Shape;182;p24"/>
+          <p:cNvPr id="225" name="Google Shape;225;p24"/>
           <p:cNvSpPr txBox="1"/>
           <p:nvPr>
             <p:ph type="title"/>
@@ -9214,7 +9541,7 @@
         </p:nvSpPr>
         <p:spPr>
           <a:xfrm>
-            <a:off x="311700" y="410000"/>
+            <a:off x="173475" y="88775"/>
             <a:ext cx="5638800" cy="607800"/>
           </a:xfrm>
           <a:prstGeom prst="rect">
@@ -9254,7 +9581,7 @@
       </p:sp>
       <p:sp>
         <p:nvSpPr>
-          <p:cNvPr id="183" name="Google Shape;183;p24"/>
+          <p:cNvPr id="226" name="Google Shape;226;p24"/>
           <p:cNvSpPr txBox="1"/>
           <p:nvPr>
             <p:ph idx="1" type="body"/>
@@ -9262,8 +9589,8 @@
         </p:nvSpPr>
         <p:spPr>
           <a:xfrm>
-            <a:off x="311700" y="1363025"/>
-            <a:ext cx="8533500" cy="2712600"/>
+            <a:off x="305250" y="1126100"/>
+            <a:ext cx="8533500" cy="3040500"/>
           </a:xfrm>
           <a:prstGeom prst="rect">
             <a:avLst/>
@@ -9271,7 +9598,7 @@
         </p:spPr>
         <p:txBody>
           <a:bodyPr anchorCtr="0" anchor="t" bIns="91425" lIns="91425" spcFirstLastPara="1" rIns="91425" wrap="square" tIns="91425">
-            <a:normAutofit fontScale="70000"/>
+            <a:normAutofit fontScale="77500" lnSpcReduction="20000"/>
           </a:bodyPr>
           <a:lstStyle/>
           <a:p>
@@ -9286,12 +9613,16 @@
             </a:pPr>
             <a:r>
               <a:rPr b="1" lang="es"/>
-              <a:t>Etapa 1 del desarrollo:</a:t>
+              <a:t>Resultados obtenidos</a:t>
+            </a:r>
+            <a:r>
+              <a:rPr b="1" lang="es"/>
+              <a:t>:</a:t>
             </a:r>
             <a:endParaRPr b="1"/>
           </a:p>
           <a:p>
-            <a:pPr indent="-308610" lvl="0" marL="457200" rtl="0" algn="l">
+            <a:pPr indent="-317182" lvl="0" marL="457200" rtl="0" algn="l">
               <a:spcBef>
                 <a:spcPts val="1200"/>
               </a:spcBef>
@@ -9303,20 +9634,12 @@
             </a:pPr>
             <a:r>
               <a:rPr b="1" lang="es"/>
-              <a:t>Construimos una base datos bien estructurada y </a:t>
-            </a:r>
-            <a:r>
-              <a:rPr b="1" lang="es"/>
-              <a:t>sólida</a:t>
-            </a:r>
-            <a:r>
-              <a:rPr b="1" lang="es"/>
-              <a:t>.</a:t>
+              <a:t>Base de datos bien estructurada y escalable</a:t>
             </a:r>
             <a:endParaRPr b="1"/>
           </a:p>
           <a:p>
-            <a:pPr indent="-308610" lvl="0" marL="457200" rtl="0" algn="l">
+            <a:pPr indent="-317182" lvl="0" marL="457200" rtl="0" algn="l">
               <a:spcBef>
                 <a:spcPts val="0"/>
               </a:spcBef>
@@ -9328,12 +9651,12 @@
             </a:pPr>
             <a:r>
               <a:rPr b="1" lang="es"/>
-              <a:t>Configuramos de manera robusta y eficiente los endpoints necesarios para la aplicación.</a:t>
+              <a:t>Perfiles de usuario, organizador y administrador configurables</a:t>
             </a:r>
             <a:endParaRPr b="1"/>
           </a:p>
           <a:p>
-            <a:pPr indent="-308610" lvl="0" marL="457200" rtl="0" algn="l">
+            <a:pPr indent="-317182" lvl="0" marL="457200" rtl="0" algn="l">
               <a:spcBef>
                 <a:spcPts val="0"/>
               </a:spcBef>
@@ -9345,28 +9668,12 @@
             </a:pPr>
             <a:r>
               <a:rPr b="1" lang="es"/>
-              <a:t>Desarrollar una </a:t>
-            </a:r>
-            <a:r>
-              <a:rPr b="1" lang="es"/>
-              <a:t>lógica</a:t>
-            </a:r>
-            <a:r>
-              <a:rPr b="1" lang="es"/>
-              <a:t> de servidor coherente y </a:t>
-            </a:r>
-            <a:r>
-              <a:rPr b="1" lang="es"/>
-              <a:t>alineada</a:t>
-            </a:r>
-            <a:r>
-              <a:rPr b="1" lang="es"/>
-              <a:t> con los requerimientos funcionales.</a:t>
+              <a:t>Creación, listado, aprobación y detalles de eventos</a:t>
             </a:r>
             <a:endParaRPr b="1"/>
           </a:p>
           <a:p>
-            <a:pPr indent="-308610" lvl="0" marL="457200" rtl="0" algn="l">
+            <a:pPr indent="-317182" lvl="0" marL="457200" rtl="0" algn="l">
               <a:spcBef>
                 <a:spcPts val="0"/>
               </a:spcBef>
@@ -9378,7 +9685,45 @@
             </a:pPr>
             <a:r>
               <a:rPr b="1" lang="es"/>
-              <a:t>Verificamos la correspondencia entre el diseño del front-end y la estructura de datos definida en el back-end.</a:t>
+              <a:t>Localización de eventos en mapa interactivo</a:t>
+            </a:r>
+            <a:endParaRPr b="1"/>
+          </a:p>
+          <a:p>
+            <a:pPr indent="-317182" lvl="0" marL="457200" rtl="0" algn="l">
+              <a:spcBef>
+                <a:spcPts val="0"/>
+              </a:spcBef>
+              <a:spcAft>
+                <a:spcPts val="0"/>
+              </a:spcAft>
+              <a:buSzPct val="100000"/>
+              <a:buChar char="●"/>
+            </a:pPr>
+            <a:r>
+              <a:rPr b="1" lang="es"/>
+              <a:t>Copiado de url de eventos a portapapeles para compartir los mismos</a:t>
+            </a:r>
+            <a:endParaRPr b="1"/>
+          </a:p>
+          <a:p>
+            <a:pPr indent="-317182" lvl="0" marL="457200" rtl="0" algn="l">
+              <a:spcBef>
+                <a:spcPts val="0"/>
+              </a:spcBef>
+              <a:spcAft>
+                <a:spcPts val="0"/>
+              </a:spcAft>
+              <a:buSzPct val="100000"/>
+              <a:buChar char="●"/>
+            </a:pPr>
+            <a:r>
+              <a:rPr b="1" lang="es"/>
+              <a:t>Búsqueda</a:t>
+            </a:r>
+            <a:r>
+              <a:rPr b="1" lang="es"/>
+              <a:t> avanzada de eventos</a:t>
             </a:r>
             <a:endParaRPr b="1"/>
           </a:p>
@@ -9394,7 +9739,7 @@
             </a:pPr>
             <a:r>
               <a:rPr b="1" lang="es"/>
-              <a:t>Obstáculos</a:t>
+              <a:t>Obstáculos principales</a:t>
             </a:r>
             <a:r>
               <a:rPr b="1" lang="es"/>
@@ -9403,7 +9748,7 @@
             <a:endParaRPr b="1"/>
           </a:p>
           <a:p>
-            <a:pPr indent="-308610" lvl="0" marL="457200" rtl="0" algn="l">
+            <a:pPr indent="-317182" lvl="0" marL="457200" rtl="0" algn="l">
               <a:spcBef>
                 <a:spcPts val="1200"/>
               </a:spcBef>
@@ -9415,7 +9760,32 @@
             </a:pPr>
             <a:r>
               <a:rPr b="1" lang="es"/>
-              <a:t>Durante esta fase inicial surgieron diversas dificultades técnicas, especialmente relacionadas con el aprendizaje y adaptación a las tecnologías seleccionadas. El proceso de familiarización con nuevas herramientas implicó una curva de aprendizaje considerable que impactó en los tiempos de avance.</a:t>
+              <a:t>Al inicio enfrentamos desafíos técnicos por la adaptación a nuevas tecnologías, lo que generó una curva de aprendizaje que afectó los tiempos de desarrollo</a:t>
+            </a:r>
+            <a:endParaRPr b="1"/>
+          </a:p>
+          <a:p>
+            <a:pPr indent="-317182" lvl="0" marL="457200" rtl="0" algn="l">
+              <a:spcBef>
+                <a:spcPts val="0"/>
+              </a:spcBef>
+              <a:spcAft>
+                <a:spcPts val="0"/>
+              </a:spcAft>
+              <a:buSzPct val="100000"/>
+              <a:buChar char="●"/>
+            </a:pPr>
+            <a:r>
+              <a:rPr b="1" lang="es"/>
+              <a:t>Se </a:t>
+            </a:r>
+            <a:r>
+              <a:rPr b="1" lang="es"/>
+              <a:t>repitió</a:t>
+            </a:r>
+            <a:r>
+              <a:rPr b="1" lang="es"/>
+              <a:t> varias veces el apartado de la base de datos para aguantar mejoras posteriores</a:t>
             </a:r>
             <a:endParaRPr b="1"/>
           </a:p>
@@ -9423,7 +9793,7 @@
       </p:sp>
       <p:pic>
         <p:nvPicPr>
-          <p:cNvPr descr="EscuelaIT Duoc UC - Escuela de Informática y Telecomunicaciones Duoc UC - Duoc  UC | LinkedIn" id="184" name="Google Shape;184;p24"/>
+          <p:cNvPr descr="EscuelaIT Duoc UC - Escuela de Informática y Telecomunicaciones Duoc UC - Duoc  UC | LinkedIn" id="227" name="Google Shape;227;p24"/>
           <p:cNvPicPr preferRelativeResize="0"/>
           <p:nvPr/>
         </p:nvPicPr>
@@ -9461,7 +9831,7 @@
   <p:cSld>
     <p:spTree>
       <p:nvGrpSpPr>
-        <p:cNvPr id="188" name="Shape 188"/>
+        <p:cNvPr id="231" name="Shape 231"/>
         <p:cNvGrpSpPr/>
         <p:nvPr/>
       </p:nvGrpSpPr>
@@ -9475,7 +9845,7 @@
       </p:grpSpPr>
       <p:sp>
         <p:nvSpPr>
-          <p:cNvPr id="189" name="Google Shape;189;p25"/>
+          <p:cNvPr id="232" name="Google Shape;232;p25"/>
           <p:cNvSpPr txBox="1"/>
           <p:nvPr>
             <p:ph type="title"/>
@@ -9515,7 +9885,7 @@
       </p:sp>
       <p:pic>
         <p:nvPicPr>
-          <p:cNvPr descr="EscuelaIT Duoc UC - Escuela de Informática y Telecomunicaciones Duoc UC - Duoc  UC | LinkedIn" id="190" name="Google Shape;190;p25"/>
+          <p:cNvPr descr="EscuelaIT Duoc UC - Escuela de Informática y Telecomunicaciones Duoc UC - Duoc  UC | LinkedIn" id="233" name="Google Shape;233;p25"/>
           <p:cNvPicPr preferRelativeResize="0"/>
           <p:nvPr/>
         </p:nvPicPr>
@@ -9542,7 +9912,7 @@
       </p:pic>
       <p:pic>
         <p:nvPicPr>
-          <p:cNvPr id="191" name="Google Shape;191;p25"/>
+          <p:cNvPr id="234" name="Google Shape;234;p25"/>
           <p:cNvPicPr preferRelativeResize="0"/>
           <p:nvPr/>
         </p:nvPicPr>
@@ -9581,7 +9951,7 @@
   <p:cSld>
     <p:spTree>
       <p:nvGrpSpPr>
-        <p:cNvPr id="195" name="Shape 195"/>
+        <p:cNvPr id="238" name="Shape 238"/>
         <p:cNvGrpSpPr/>
         <p:nvPr/>
       </p:nvGrpSpPr>
@@ -9595,7 +9965,7 @@
       </p:grpSpPr>
       <p:sp>
         <p:nvSpPr>
-          <p:cNvPr id="196" name="Google Shape;196;p26"/>
+          <p:cNvPr id="239" name="Google Shape;239;p26"/>
           <p:cNvSpPr txBox="1"/>
           <p:nvPr>
             <p:ph type="title"/>
@@ -9603,7 +9973,397 @@
         </p:nvSpPr>
         <p:spPr>
           <a:xfrm>
-            <a:off x="2367450" y="1706975"/>
+            <a:off x="193225" y="88775"/>
+            <a:ext cx="8520600" cy="607800"/>
+          </a:xfrm>
+          <a:prstGeom prst="rect">
+            <a:avLst/>
+          </a:prstGeom>
+        </p:spPr>
+        <p:txBody>
+          <a:bodyPr anchorCtr="0" anchor="t" bIns="91425" lIns="91425" spcFirstLastPara="1" rIns="91425" wrap="square" tIns="91425">
+            <a:normAutofit fontScale="90000"/>
+          </a:bodyPr>
+          <a:lstStyle/>
+          <a:p>
+            <a:pPr indent="0" lvl="0" marL="0" rtl="0" algn="l">
+              <a:spcBef>
+                <a:spcPts val="0"/>
+              </a:spcBef>
+              <a:spcAft>
+                <a:spcPts val="0"/>
+              </a:spcAft>
+              <a:buNone/>
+            </a:pPr>
+            <a:r>
+              <a:rPr b="1" lang="es"/>
+              <a:t>Cierre</a:t>
+            </a:r>
+            <a:endParaRPr b="1"/>
+          </a:p>
+        </p:txBody>
+      </p:sp>
+      <p:sp>
+        <p:nvSpPr>
+          <p:cNvPr id="240" name="Google Shape;240;p26"/>
+          <p:cNvSpPr txBox="1"/>
+          <p:nvPr>
+            <p:ph idx="1" type="body"/>
+          </p:nvPr>
+        </p:nvSpPr>
+        <p:spPr>
+          <a:xfrm>
+            <a:off x="311700" y="587975"/>
+            <a:ext cx="7050600" cy="3339000"/>
+          </a:xfrm>
+          <a:prstGeom prst="rect">
+            <a:avLst/>
+          </a:prstGeom>
+        </p:spPr>
+        <p:txBody>
+          <a:bodyPr anchorCtr="0" anchor="t" bIns="91425" lIns="91425" spcFirstLastPara="1" rIns="91425" wrap="square" tIns="91425">
+            <a:normAutofit lnSpcReduction="20000"/>
+          </a:bodyPr>
+          <a:lstStyle/>
+          <a:p>
+            <a:pPr indent="-304800" lvl="0" marL="457200" rtl="0" algn="l">
+              <a:spcBef>
+                <a:spcPts val="1200"/>
+              </a:spcBef>
+              <a:spcAft>
+                <a:spcPts val="0"/>
+              </a:spcAft>
+              <a:buClr>
+                <a:srgbClr val="000000"/>
+              </a:buClr>
+              <a:buSzPts val="1200"/>
+              <a:buChar char="●"/>
+            </a:pPr>
+            <a:r>
+              <a:rPr b="1" lang="es" sz="1200">
+                <a:solidFill>
+                  <a:srgbClr val="000000"/>
+                </a:solidFill>
+              </a:rPr>
+              <a:t>Asistencia</a:t>
+            </a:r>
+            <a:endParaRPr b="1" sz="1200">
+              <a:solidFill>
+                <a:srgbClr val="000000"/>
+              </a:solidFill>
+            </a:endParaRPr>
+          </a:p>
+          <a:p>
+            <a:pPr indent="-304800" lvl="1" marL="914400" marR="381000" rtl="0" algn="l">
+              <a:spcBef>
+                <a:spcPts val="0"/>
+              </a:spcBef>
+              <a:spcAft>
+                <a:spcPts val="0"/>
+              </a:spcAft>
+              <a:buClr>
+                <a:srgbClr val="000000"/>
+              </a:buClr>
+              <a:buSzPts val="1200"/>
+              <a:buChar char="○"/>
+            </a:pPr>
+            <a:r>
+              <a:rPr lang="es" sz="1200">
+                <a:solidFill>
+                  <a:srgbClr val="000000"/>
+                </a:solidFill>
+              </a:rPr>
+              <a:t>Facilita que más personas descubran eventos a tiempo gracias a la publicación organizada</a:t>
+            </a:r>
+            <a:endParaRPr sz="1200">
+              <a:solidFill>
+                <a:srgbClr val="000000"/>
+              </a:solidFill>
+            </a:endParaRPr>
+          </a:p>
+          <a:p>
+            <a:pPr indent="-304800" lvl="0" marL="457200" rtl="0" algn="l">
+              <a:spcBef>
+                <a:spcPts val="0"/>
+              </a:spcBef>
+              <a:spcAft>
+                <a:spcPts val="0"/>
+              </a:spcAft>
+              <a:buClr>
+                <a:srgbClr val="000000"/>
+              </a:buClr>
+              <a:buSzPts val="1200"/>
+              <a:buFont typeface="Arial"/>
+              <a:buChar char="●"/>
+            </a:pPr>
+            <a:r>
+              <a:rPr lang="es" sz="1200">
+                <a:solidFill>
+                  <a:srgbClr val="000000"/>
+                </a:solidFill>
+              </a:rPr>
+              <a:t> </a:t>
+            </a:r>
+            <a:r>
+              <a:rPr b="1" lang="es" sz="1200">
+                <a:solidFill>
+                  <a:srgbClr val="000000"/>
+                </a:solidFill>
+              </a:rPr>
+              <a:t>Interacción</a:t>
+            </a:r>
+            <a:endParaRPr b="1" sz="1200">
+              <a:solidFill>
+                <a:srgbClr val="000000"/>
+              </a:solidFill>
+            </a:endParaRPr>
+          </a:p>
+          <a:p>
+            <a:pPr indent="-304800" lvl="1" marL="914400" marR="381000" rtl="0" algn="l">
+              <a:spcBef>
+                <a:spcPts val="0"/>
+              </a:spcBef>
+              <a:spcAft>
+                <a:spcPts val="0"/>
+              </a:spcAft>
+              <a:buClr>
+                <a:srgbClr val="000000"/>
+              </a:buClr>
+              <a:buSzPts val="1200"/>
+              <a:buChar char="○"/>
+            </a:pPr>
+            <a:r>
+              <a:rPr lang="es" sz="1200">
+                <a:solidFill>
+                  <a:srgbClr val="000000"/>
+                </a:solidFill>
+              </a:rPr>
+              <a:t>Funcionalidades como búsqueda con filtros, detalles de eventos y favoritos aumentan el interés del usuario</a:t>
+            </a:r>
+            <a:endParaRPr sz="1200">
+              <a:solidFill>
+                <a:srgbClr val="000000"/>
+              </a:solidFill>
+            </a:endParaRPr>
+          </a:p>
+          <a:p>
+            <a:pPr indent="-304800" lvl="0" marL="457200" rtl="0" algn="l">
+              <a:spcBef>
+                <a:spcPts val="0"/>
+              </a:spcBef>
+              <a:spcAft>
+                <a:spcPts val="0"/>
+              </a:spcAft>
+              <a:buClr>
+                <a:srgbClr val="000000"/>
+              </a:buClr>
+              <a:buSzPts val="1200"/>
+              <a:buChar char="●"/>
+            </a:pPr>
+            <a:r>
+              <a:rPr b="1" lang="es" sz="1200">
+                <a:solidFill>
+                  <a:srgbClr val="000000"/>
+                </a:solidFill>
+              </a:rPr>
+              <a:t>Proyección de ventas</a:t>
+            </a:r>
+            <a:endParaRPr b="1" sz="1200">
+              <a:solidFill>
+                <a:srgbClr val="000000"/>
+              </a:solidFill>
+            </a:endParaRPr>
+          </a:p>
+          <a:p>
+            <a:pPr indent="-304800" lvl="1" marL="914400" marR="381000" rtl="0" algn="l">
+              <a:spcBef>
+                <a:spcPts val="0"/>
+              </a:spcBef>
+              <a:spcAft>
+                <a:spcPts val="0"/>
+              </a:spcAft>
+              <a:buClr>
+                <a:srgbClr val="000000"/>
+              </a:buClr>
+              <a:buSzPts val="1200"/>
+              <a:buChar char="○"/>
+            </a:pPr>
+            <a:r>
+              <a:rPr lang="es" sz="1200">
+                <a:solidFill>
+                  <a:srgbClr val="000000"/>
+                </a:solidFill>
+              </a:rPr>
+              <a:t>La estructura de eventos y visibilidad sentará las bases para futuras integraciones de entradas}</a:t>
+            </a:r>
+            <a:endParaRPr sz="1200">
+              <a:solidFill>
+                <a:srgbClr val="000000"/>
+              </a:solidFill>
+            </a:endParaRPr>
+          </a:p>
+          <a:p>
+            <a:pPr indent="0" lvl="0" marL="0" rtl="0" algn="l">
+              <a:spcBef>
+                <a:spcPts val="1200"/>
+              </a:spcBef>
+              <a:spcAft>
+                <a:spcPts val="0"/>
+              </a:spcAft>
+              <a:buNone/>
+            </a:pPr>
+            <a:r>
+              <a:rPr b="1" lang="es" sz="1200">
+                <a:solidFill>
+                  <a:srgbClr val="000000"/>
+                </a:solidFill>
+              </a:rPr>
+              <a:t>Impacto directo</a:t>
+            </a:r>
+            <a:endParaRPr b="1" sz="1200">
+              <a:solidFill>
+                <a:srgbClr val="000000"/>
+              </a:solidFill>
+            </a:endParaRPr>
+          </a:p>
+          <a:p>
+            <a:pPr indent="-304800" lvl="0" marL="457200" rtl="0" algn="l">
+              <a:spcBef>
+                <a:spcPts val="1200"/>
+              </a:spcBef>
+              <a:spcAft>
+                <a:spcPts val="0"/>
+              </a:spcAft>
+              <a:buClr>
+                <a:srgbClr val="000000"/>
+              </a:buClr>
+              <a:buSzPts val="1200"/>
+              <a:buFont typeface="Arial"/>
+              <a:buChar char="●"/>
+            </a:pPr>
+            <a:r>
+              <a:rPr b="1" lang="es" sz="1200">
+                <a:solidFill>
+                  <a:srgbClr val="000000"/>
+                </a:solidFill>
+              </a:rPr>
+              <a:t>Usuarios</a:t>
+            </a:r>
+            <a:r>
+              <a:rPr lang="es" sz="1200">
+                <a:solidFill>
+                  <a:srgbClr val="000000"/>
+                </a:solidFill>
+              </a:rPr>
+              <a:t> → Descubren más eventos con facilidad</a:t>
+            </a:r>
+            <a:br>
+              <a:rPr lang="es" sz="1200">
+                <a:solidFill>
+                  <a:srgbClr val="000000"/>
+                </a:solidFill>
+              </a:rPr>
+            </a:br>
+            <a:endParaRPr sz="1200">
+              <a:solidFill>
+                <a:srgbClr val="000000"/>
+              </a:solidFill>
+            </a:endParaRPr>
+          </a:p>
+          <a:p>
+            <a:pPr indent="-304800" lvl="0" marL="457200" rtl="0" algn="l">
+              <a:spcBef>
+                <a:spcPts val="0"/>
+              </a:spcBef>
+              <a:spcAft>
+                <a:spcPts val="0"/>
+              </a:spcAft>
+              <a:buClr>
+                <a:srgbClr val="000000"/>
+              </a:buClr>
+              <a:buSzPts val="1200"/>
+              <a:buFont typeface="Arial"/>
+              <a:buChar char="●"/>
+            </a:pPr>
+            <a:r>
+              <a:rPr b="1" lang="es" sz="1200">
+                <a:solidFill>
+                  <a:srgbClr val="000000"/>
+                </a:solidFill>
+              </a:rPr>
+              <a:t>Organizadores</a:t>
+            </a:r>
+            <a:r>
+              <a:rPr lang="es" sz="1200">
+                <a:solidFill>
+                  <a:srgbClr val="000000"/>
+                </a:solidFill>
+              </a:rPr>
+              <a:t> → Mayor visibilidad y control de sus eventos</a:t>
+            </a:r>
+            <a:br>
+              <a:rPr lang="es" sz="1200">
+                <a:solidFill>
+                  <a:srgbClr val="000000"/>
+                </a:solidFill>
+              </a:rPr>
+            </a:br>
+            <a:endParaRPr sz="1200">
+              <a:solidFill>
+                <a:srgbClr val="000000"/>
+              </a:solidFill>
+            </a:endParaRPr>
+          </a:p>
+          <a:p>
+            <a:pPr indent="-304800" lvl="0" marL="457200" rtl="0" algn="l">
+              <a:spcBef>
+                <a:spcPts val="0"/>
+              </a:spcBef>
+              <a:spcAft>
+                <a:spcPts val="0"/>
+              </a:spcAft>
+              <a:buClr>
+                <a:srgbClr val="000000"/>
+              </a:buClr>
+              <a:buSzPts val="1200"/>
+              <a:buFont typeface="Arial"/>
+              <a:buChar char="●"/>
+            </a:pPr>
+            <a:r>
+              <a:rPr b="1" lang="es" sz="1200">
+                <a:solidFill>
+                  <a:srgbClr val="000000"/>
+                </a:solidFill>
+              </a:rPr>
+              <a:t>Comunidad</a:t>
+            </a:r>
+            <a:r>
+              <a:rPr lang="es" sz="1200">
+                <a:solidFill>
+                  <a:srgbClr val="000000"/>
+                </a:solidFill>
+              </a:rPr>
+              <a:t> → Se fortalece la vida cultural y social</a:t>
+            </a:r>
+            <a:endParaRPr sz="1200">
+              <a:solidFill>
+                <a:srgbClr val="000000"/>
+              </a:solidFill>
+            </a:endParaRPr>
+          </a:p>
+        </p:txBody>
+      </p:sp>
+      <p:sp>
+        <p:nvSpPr>
+          <p:cNvPr id="241" name="Google Shape;241;p26"/>
+          <p:cNvSpPr txBox="1"/>
+          <p:nvPr>
+            <p:ph type="title"/>
+          </p:nvPr>
+        </p:nvSpPr>
+        <p:spPr>
+          <a:xfrm>
+            <a:off x="2367450" y="3839400"/>
             <a:ext cx="4409100" cy="1002900"/>
           </a:xfrm>
           <a:prstGeom prst="rect">
@@ -9651,7 +10411,7 @@
       </p:sp>
       <p:pic>
         <p:nvPicPr>
-          <p:cNvPr descr="EscuelaIT Duoc UC - Escuela de Informática y Telecomunicaciones Duoc UC - Duoc  UC | LinkedIn" id="197" name="Google Shape;197;p26"/>
+          <p:cNvPr descr="EscuelaIT Duoc UC - Escuela de Informática y Telecomunicaciones Duoc UC - Duoc  UC | LinkedIn" id="242" name="Google Shape;242;p26"/>
           <p:cNvPicPr preferRelativeResize="0"/>
           <p:nvPr/>
         </p:nvPicPr>
@@ -9666,6 +10426,174 @@
           <a:xfrm>
             <a:off x="6002602" y="0"/>
             <a:ext cx="3141406" cy="785352"/>
+          </a:xfrm>
+          <a:prstGeom prst="rect">
+            <a:avLst/>
+          </a:prstGeom>
+          <a:noFill/>
+          <a:ln>
+            <a:noFill/>
+          </a:ln>
+        </p:spPr>
+      </p:pic>
+      <p:pic>
+        <p:nvPicPr>
+          <p:cNvPr id="243" name="Google Shape;243;p26"/>
+          <p:cNvPicPr preferRelativeResize="0"/>
+          <p:nvPr/>
+        </p:nvPicPr>
+        <p:blipFill>
+          <a:blip r:embed="rId4">
+            <a:alphaModFix/>
+          </a:blip>
+          <a:stretch>
+            <a:fillRect/>
+          </a:stretch>
+        </p:blipFill>
+        <p:spPr>
+          <a:xfrm>
+            <a:off x="7099425" y="587975"/>
+            <a:ext cx="617275" cy="617275"/>
+          </a:xfrm>
+          <a:prstGeom prst="rect">
+            <a:avLst/>
+          </a:prstGeom>
+          <a:noFill/>
+          <a:ln>
+            <a:noFill/>
+          </a:ln>
+        </p:spPr>
+      </p:pic>
+      <p:pic>
+        <p:nvPicPr>
+          <p:cNvPr id="244" name="Google Shape;244;p26"/>
+          <p:cNvPicPr preferRelativeResize="0"/>
+          <p:nvPr/>
+        </p:nvPicPr>
+        <p:blipFill>
+          <a:blip r:embed="rId5">
+            <a:alphaModFix/>
+          </a:blip>
+          <a:stretch>
+            <a:fillRect/>
+          </a:stretch>
+        </p:blipFill>
+        <p:spPr>
+          <a:xfrm>
+            <a:off x="7264663" y="1307125"/>
+            <a:ext cx="617275" cy="617275"/>
+          </a:xfrm>
+          <a:prstGeom prst="rect">
+            <a:avLst/>
+          </a:prstGeom>
+          <a:noFill/>
+          <a:ln>
+            <a:noFill/>
+          </a:ln>
+        </p:spPr>
+      </p:pic>
+      <p:pic>
+        <p:nvPicPr>
+          <p:cNvPr id="245" name="Google Shape;245;p26"/>
+          <p:cNvPicPr preferRelativeResize="0"/>
+          <p:nvPr/>
+        </p:nvPicPr>
+        <p:blipFill>
+          <a:blip r:embed="rId6">
+            <a:alphaModFix/>
+          </a:blip>
+          <a:stretch>
+            <a:fillRect/>
+          </a:stretch>
+        </p:blipFill>
+        <p:spPr>
+          <a:xfrm>
+            <a:off x="7206750" y="2122725"/>
+            <a:ext cx="617251" cy="617251"/>
+          </a:xfrm>
+          <a:prstGeom prst="rect">
+            <a:avLst/>
+          </a:prstGeom>
+          <a:noFill/>
+          <a:ln>
+            <a:noFill/>
+          </a:ln>
+        </p:spPr>
+      </p:pic>
+      <p:pic>
+        <p:nvPicPr>
+          <p:cNvPr id="246" name="Google Shape;246;p26"/>
+          <p:cNvPicPr preferRelativeResize="0"/>
+          <p:nvPr/>
+        </p:nvPicPr>
+        <p:blipFill>
+          <a:blip r:embed="rId7">
+            <a:alphaModFix/>
+          </a:blip>
+          <a:stretch>
+            <a:fillRect/>
+          </a:stretch>
+        </p:blipFill>
+        <p:spPr>
+          <a:xfrm>
+            <a:off x="4871325" y="2263125"/>
+            <a:ext cx="617251" cy="617251"/>
+          </a:xfrm>
+          <a:prstGeom prst="rect">
+            <a:avLst/>
+          </a:prstGeom>
+          <a:noFill/>
+          <a:ln>
+            <a:noFill/>
+          </a:ln>
+        </p:spPr>
+      </p:pic>
+      <p:pic>
+        <p:nvPicPr>
+          <p:cNvPr id="247" name="Google Shape;247;p26"/>
+          <p:cNvPicPr preferRelativeResize="0"/>
+          <p:nvPr/>
+        </p:nvPicPr>
+        <p:blipFill>
+          <a:blip r:embed="rId8">
+            <a:alphaModFix/>
+          </a:blip>
+          <a:stretch>
+            <a:fillRect/>
+          </a:stretch>
+        </p:blipFill>
+        <p:spPr>
+          <a:xfrm>
+            <a:off x="5488575" y="2820675"/>
+            <a:ext cx="617275" cy="617275"/>
+          </a:xfrm>
+          <a:prstGeom prst="rect">
+            <a:avLst/>
+          </a:prstGeom>
+          <a:noFill/>
+          <a:ln>
+            <a:noFill/>
+          </a:ln>
+        </p:spPr>
+      </p:pic>
+      <p:pic>
+        <p:nvPicPr>
+          <p:cNvPr id="248" name="Google Shape;248;p26"/>
+          <p:cNvPicPr preferRelativeResize="0"/>
+          <p:nvPr/>
+        </p:nvPicPr>
+        <p:blipFill>
+          <a:blip r:embed="rId9">
+            <a:alphaModFix/>
+          </a:blip>
+          <a:stretch>
+            <a:fillRect/>
+          </a:stretch>
+        </p:blipFill>
+        <p:spPr>
+          <a:xfrm>
+            <a:off x="4719200" y="3309700"/>
+            <a:ext cx="617275" cy="617275"/>
           </a:xfrm>
           <a:prstGeom prst="rect">
             <a:avLst/>
@@ -9738,7 +10666,7 @@
         </p:nvSpPr>
         <p:spPr>
           <a:xfrm>
-            <a:off x="56375" y="88775"/>
+            <a:off x="95850" y="88775"/>
             <a:ext cx="3692400" cy="607800"/>
           </a:xfrm>
           <a:prstGeom prst="rect">
@@ -10018,7 +10946,7 @@
                 <a:cs typeface="Roboto"/>
                 <a:sym typeface="Roboto"/>
               </a:rPr>
-              <a:t>Desarrollo frontend con Next.js y Tailwind, diseño de interfaz, validación de formularios, documentación técnica, modelado de base de datos y arquitectura</a:t>
+              <a:t>Desarrollo frontend con Next.js y Tailwind, diseño de interfaz, validación de formularios, documentación técnica y modelado de base de datos.</a:t>
             </a:r>
             <a:endParaRPr b="1" i="1" sz="1500">
               <a:solidFill>
@@ -10199,7 +11127,7 @@
         </p:nvSpPr>
         <p:spPr>
           <a:xfrm>
-            <a:off x="311700" y="410000"/>
+            <a:off x="84625" y="88775"/>
             <a:ext cx="8520600" cy="607800"/>
           </a:xfrm>
           <a:prstGeom prst="rect">
@@ -10239,7 +11167,7 @@
         </p:nvSpPr>
         <p:spPr>
           <a:xfrm>
-            <a:off x="311700" y="1017800"/>
+            <a:off x="311700" y="754488"/>
             <a:ext cx="8520600" cy="992100"/>
           </a:xfrm>
           <a:prstGeom prst="rect">
@@ -10313,7 +11241,7 @@
         </p:nvSpPr>
         <p:spPr>
           <a:xfrm>
-            <a:off x="370950" y="1804500"/>
+            <a:off x="311700" y="1656425"/>
             <a:ext cx="8520600" cy="3152100"/>
           </a:xfrm>
           <a:prstGeom prst="rect">
@@ -10658,7 +11586,7 @@
         </p:nvSpPr>
         <p:spPr>
           <a:xfrm>
-            <a:off x="311700" y="410000"/>
+            <a:off x="83925" y="88775"/>
             <a:ext cx="8520600" cy="607800"/>
           </a:xfrm>
           <a:prstGeom prst="rect">
@@ -10698,7 +11626,7 @@
         </p:nvSpPr>
         <p:spPr>
           <a:xfrm>
-            <a:off x="311700" y="1229875"/>
+            <a:off x="311700" y="902250"/>
             <a:ext cx="7178400" cy="3339000"/>
           </a:xfrm>
           <a:prstGeom prst="rect">
@@ -10707,7 +11635,7 @@
         </p:spPr>
         <p:txBody>
           <a:bodyPr anchorCtr="0" anchor="t" bIns="91425" lIns="91425" spcFirstLastPara="1" rIns="91425" wrap="square" tIns="91425">
-            <a:normAutofit lnSpcReduction="10000"/>
+            <a:normAutofit/>
           </a:bodyPr>
           <a:lstStyle/>
           <a:p>
@@ -10786,9 +11714,6 @@
           </a:p>
           <a:p>
             <a:pPr indent="-304800" lvl="0" marL="457200" rtl="0" algn="l">
-              <a:lnSpc>
-                <a:spcPct val="115000"/>
-              </a:lnSpc>
               <a:spcBef>
                 <a:spcPts val="1200"/>
               </a:spcBef>
@@ -10807,8 +11732,15 @@
                   <a:srgbClr val="000000"/>
                 </a:solidFill>
               </a:rPr>
-              <a:t>Lograr un aumento de al menos un 30% en la asistencia a eventos  los 6 primeros meses de implementación de la plataforma.</a:t>
+              <a:t>Aumentar la asistencia a eventos en un 30% en los primeros 6 meses.</a:t>
             </a:r>
+            <a:br>
+              <a:rPr lang="es" sz="1400">
+                <a:solidFill>
+                  <a:srgbClr val="000000"/>
+                </a:solidFill>
+              </a:rPr>
+            </a:br>
             <a:endParaRPr sz="1400">
               <a:solidFill>
                 <a:srgbClr val="000000"/>
@@ -10817,9 +11749,6 @@
           </a:p>
           <a:p>
             <a:pPr indent="-304800" lvl="0" marL="457200" rtl="0" algn="l">
-              <a:lnSpc>
-                <a:spcPct val="115000"/>
-              </a:lnSpc>
               <a:spcBef>
                 <a:spcPts val="0"/>
               </a:spcBef>
@@ -10838,8 +11767,15 @@
                   <a:srgbClr val="000000"/>
                 </a:solidFill>
               </a:rPr>
-              <a:t>Aumentar al menos un 25% la interacción de los usuarios con los eventos publicados en los primeros 3 meses de implementación de la plataforma.</a:t>
+              <a:t>Incrementar la interacción de usuarios con eventos en un 25% en 3 meses.</a:t>
             </a:r>
+            <a:br>
+              <a:rPr lang="es" sz="1400">
+                <a:solidFill>
+                  <a:srgbClr val="000000"/>
+                </a:solidFill>
+              </a:rPr>
+            </a:br>
             <a:endParaRPr sz="1400">
               <a:solidFill>
                 <a:srgbClr val="000000"/>
@@ -10848,9 +11784,6 @@
           </a:p>
           <a:p>
             <a:pPr indent="-304800" lvl="0" marL="457200" rtl="0" algn="l">
-              <a:lnSpc>
-                <a:spcPct val="115000"/>
-              </a:lnSpc>
               <a:spcBef>
                 <a:spcPts val="0"/>
               </a:spcBef>
@@ -10869,9 +11802,13 @@
                   <a:srgbClr val="000000"/>
                 </a:solidFill>
               </a:rPr>
-              <a:t>Lograr un aumento de un 30% en la venta de entradas de eventos luego de 1 año de implementada la plataforma.</a:t>
+              <a:t>Mejorar la venta de entradas en un 30% al cumplir 1 año de uso.</a:t>
             </a:r>
-            <a:endParaRPr sz="1900"/>
+            <a:endParaRPr sz="1400">
+              <a:solidFill>
+                <a:srgbClr val="000000"/>
+              </a:solidFill>
+            </a:endParaRPr>
           </a:p>
           <a:p>
             <a:pPr indent="0" lvl="0" marL="0" rtl="0" algn="l">
@@ -10961,7 +11898,7 @@
         </p:blipFill>
         <p:spPr>
           <a:xfrm>
-            <a:off x="7696025" y="2137250"/>
+            <a:off x="7547925" y="2090275"/>
             <a:ext cx="778696" cy="785350"/>
           </a:xfrm>
           <a:prstGeom prst="rect">
@@ -11017,7 +11954,7 @@
         </p:blipFill>
         <p:spPr>
           <a:xfrm>
-            <a:off x="5109025" y="4007350"/>
+            <a:off x="5494050" y="4036950"/>
             <a:ext cx="692050" cy="692050"/>
           </a:xfrm>
           <a:prstGeom prst="rect">
@@ -11090,7 +12027,7 @@
         <p:spPr>
           <a:xfrm>
             <a:off x="115300" y="107800"/>
-            <a:ext cx="3000000" cy="4279800"/>
+            <a:ext cx="3000000" cy="4085100"/>
           </a:xfrm>
           <a:prstGeom prst="rect">
             <a:avLst/>
@@ -11145,7 +12082,7 @@
             </a:pPr>
             <a:r>
               <a:rPr lang="es" sz="1100"/>
-              <a:t>Gestión de usuarios, roles y perfiles (administrador, organizador, usuario).</a:t>
+              <a:t>Gestión de usuarios con diferentes roles: administrador, organizador y usuario.</a:t>
             </a:r>
             <a:br>
               <a:rPr lang="es" sz="1100"/>
@@ -11168,7 +12105,7 @@
             </a:pPr>
             <a:r>
               <a:rPr lang="es" sz="1100"/>
-              <a:t>Registro, edición y publicación de eventos con categorías y estados.</a:t>
+              <a:t>Creación y publicación de eventos</a:t>
             </a:r>
             <a:br>
               <a:rPr lang="es" sz="1100"/>
@@ -11191,7 +12128,7 @@
             </a:pPr>
             <a:r>
               <a:rPr lang="es" sz="1100"/>
-              <a:t>Notificaciones por cambios de estado en eventos.</a:t>
+              <a:t>Mapa interactivo con punto anterior</a:t>
             </a:r>
             <a:br>
               <a:rPr lang="es" sz="1100"/>
@@ -11214,7 +12151,7 @@
             </a:pPr>
             <a:r>
               <a:rPr lang="es" sz="1100"/>
-              <a:t>Acreditación de organizadores controlada por administradores.</a:t>
+              <a:t>Dashboard tanto administrativas como para organizadores</a:t>
             </a:r>
             <a:br>
               <a:rPr lang="es" sz="1100"/>
@@ -11237,7 +12174,7 @@
             </a:pPr>
             <a:r>
               <a:rPr lang="es" sz="1100"/>
-              <a:t>Plataforma web responsive con Next.js, Elysia.js y Supabase.</a:t>
+              <a:t>Acreditación o aprobación de organizadores gestionada por administradores</a:t>
             </a:r>
             <a:br>
               <a:rPr lang="es" sz="1100"/>
@@ -11260,7 +12197,7 @@
             </a:pPr>
             <a:r>
               <a:rPr lang="es" sz="1100"/>
-              <a:t>Backend documentado (Swagger/Scalar) y autenticación JWT.</a:t>
+              <a:t>Plataforma web adaptable a dispositivos móviles y de escritorio</a:t>
             </a:r>
             <a:endParaRPr sz="1100"/>
           </a:p>
@@ -11275,7 +12212,7 @@
         <p:spPr>
           <a:xfrm>
             <a:off x="3953350" y="373125"/>
-            <a:ext cx="3000000" cy="3890400"/>
+            <a:ext cx="3000000" cy="2876100"/>
           </a:xfrm>
           <a:prstGeom prst="rect">
             <a:avLst/>
@@ -11342,7 +12279,11 @@
             </a:pPr>
             <a:r>
               <a:rPr lang="es" sz="1100"/>
-              <a:t>Foco inicial solo en Concepción.</a:t>
+              <a:t>Alcance </a:t>
+            </a:r>
+            <a:r>
+              <a:rPr lang="es" sz="1100"/>
+              <a:t> inicial solo en la ciudad de Concepción.</a:t>
             </a:r>
             <a:br>
               <a:rPr lang="es" sz="1100"/>
@@ -11365,7 +12306,7 @@
             </a:pPr>
             <a:r>
               <a:rPr lang="es" sz="1100"/>
-              <a:t>Sin integración con pagos ni redes sociales.</a:t>
+              <a:t>Sin integración a plataformas de pago de ningún tipo inicialmente</a:t>
             </a:r>
             <a:br>
               <a:rPr lang="es" sz="1100"/>
@@ -11388,7 +12329,7 @@
             </a:pPr>
             <a:r>
               <a:rPr lang="es" sz="1100"/>
-              <a:t>Notificaciones limitadas a cambios de estado.</a:t>
+              <a:t>Acreditación requiere de aprobación manual</a:t>
             </a:r>
             <a:br>
               <a:rPr lang="es" sz="1100"/>
@@ -11396,68 +12337,20 @@
             <a:endParaRPr sz="1100"/>
           </a:p>
           <a:p>
-            <a:pPr indent="-298450" lvl="0" marL="457200" rtl="0" algn="l">
+            <a:pPr indent="0" lvl="0" marL="457200" rtl="0" algn="l">
               <a:lnSpc>
                 <a:spcPct val="115000"/>
               </a:lnSpc>
               <a:spcBef>
-                <a:spcPts val="0"/>
-              </a:spcBef>
-              <a:spcAft>
-                <a:spcPts val="0"/>
-              </a:spcAft>
-              <a:buSzPts val="1100"/>
-              <a:buChar char="●"/>
+                <a:spcPts val="1200"/>
+              </a:spcBef>
+              <a:spcAft>
+                <a:spcPts val="1200"/>
+              </a:spcAft>
+              <a:buNone/>
             </a:pPr>
             <a:r>
-              <a:rPr lang="es" sz="1100"/>
-              <a:t>Sin recomendaciones personalizadas.</a:t>
-            </a:r>
-            <a:br>
-              <a:rPr lang="es" sz="1100"/>
-            </a:br>
-            <a:endParaRPr sz="1100"/>
-          </a:p>
-          <a:p>
-            <a:pPr indent="-298450" lvl="0" marL="457200" rtl="0" algn="l">
-              <a:lnSpc>
-                <a:spcPct val="115000"/>
-              </a:lnSpc>
-              <a:spcBef>
-                <a:spcPts val="0"/>
-              </a:spcBef>
-              <a:spcAft>
-                <a:spcPts val="0"/>
-              </a:spcAft>
-              <a:buSzPts val="1100"/>
-              <a:buChar char="●"/>
-            </a:pPr>
-            <a:r>
-              <a:rPr lang="es" sz="1100"/>
-              <a:t>Acreditación no completamente automatizada.</a:t>
-            </a:r>
-            <a:br>
-              <a:rPr lang="es" sz="1100"/>
-            </a:br>
-            <a:endParaRPr sz="1100"/>
-          </a:p>
-          <a:p>
-            <a:pPr indent="-298450" lvl="0" marL="457200" rtl="0" algn="l">
-              <a:lnSpc>
-                <a:spcPct val="115000"/>
-              </a:lnSpc>
-              <a:spcBef>
-                <a:spcPts val="0"/>
-              </a:spcBef>
-              <a:spcAft>
-                <a:spcPts val="0"/>
-              </a:spcAft>
-              <a:buSzPts val="1100"/>
-              <a:buChar char="●"/>
-            </a:pPr>
-            <a:r>
-              <a:rPr lang="es" sz="1100"/>
-              <a:t>Seguridad avanzada y alta concurrencia fuera de alcance inicial.</a:t>
+              <a:t/>
             </a:r>
             <a:endParaRPr sz="1100"/>
           </a:p>
@@ -11479,7 +12372,7 @@
         </p:blipFill>
         <p:spPr>
           <a:xfrm>
-            <a:off x="3115300" y="1026124"/>
+            <a:off x="3024750" y="265949"/>
             <a:ext cx="617275" cy="617275"/>
           </a:xfrm>
           <a:prstGeom prst="rect">
@@ -11507,7 +12400,7 @@
         </p:blipFill>
         <p:spPr>
           <a:xfrm>
-            <a:off x="3115300" y="2009689"/>
+            <a:off x="7264663" y="726426"/>
             <a:ext cx="617275" cy="617275"/>
           </a:xfrm>
           <a:prstGeom prst="rect">
@@ -11535,7 +12428,7 @@
         </p:blipFill>
         <p:spPr>
           <a:xfrm>
-            <a:off x="3050275" y="3107876"/>
+            <a:off x="3024750" y="1037651"/>
             <a:ext cx="617275" cy="617275"/>
           </a:xfrm>
           <a:prstGeom prst="rect">
@@ -11563,7 +12456,7 @@
         </p:blipFill>
         <p:spPr>
           <a:xfrm>
-            <a:off x="7264663" y="726426"/>
+            <a:off x="3115300" y="1877513"/>
             <a:ext cx="617275" cy="617275"/>
           </a:xfrm>
           <a:prstGeom prst="rect">
@@ -11591,8 +12484,8 @@
         </p:blipFill>
         <p:spPr>
           <a:xfrm>
-            <a:off x="7351225" y="1939076"/>
-            <a:ext cx="617251" cy="617251"/>
+            <a:off x="3115300" y="2494801"/>
+            <a:ext cx="617275" cy="617275"/>
           </a:xfrm>
           <a:prstGeom prst="rect">
             <a:avLst/>
@@ -11619,8 +12512,8 @@
         </p:blipFill>
         <p:spPr>
           <a:xfrm>
-            <a:off x="7351225" y="2961601"/>
-            <a:ext cx="617251" cy="617251"/>
+            <a:off x="7174125" y="2422851"/>
+            <a:ext cx="617275" cy="617275"/>
           </a:xfrm>
           <a:prstGeom prst="rect">
             <a:avLst/>
@@ -11631,6 +12524,176 @@
           </a:ln>
         </p:spPr>
       </p:pic>
+      <p:pic>
+        <p:nvPicPr>
+          <p:cNvPr id="131" name="Google Shape;131;p17"/>
+          <p:cNvPicPr preferRelativeResize="0"/>
+          <p:nvPr/>
+        </p:nvPicPr>
+        <p:blipFill>
+          <a:blip r:embed="rId10">
+            <a:alphaModFix/>
+          </a:blip>
+          <a:stretch>
+            <a:fillRect/>
+          </a:stretch>
+        </p:blipFill>
+        <p:spPr>
+          <a:xfrm>
+            <a:off x="3024750" y="3951951"/>
+            <a:ext cx="617275" cy="617275"/>
+          </a:xfrm>
+          <a:prstGeom prst="rect">
+            <a:avLst/>
+          </a:prstGeom>
+          <a:noFill/>
+          <a:ln>
+            <a:noFill/>
+          </a:ln>
+        </p:spPr>
+      </p:pic>
+      <p:grpSp>
+        <p:nvGrpSpPr>
+          <p:cNvPr id="132" name="Google Shape;132;p17"/>
+          <p:cNvGrpSpPr/>
+          <p:nvPr/>
+        </p:nvGrpSpPr>
+        <p:grpSpPr>
+          <a:xfrm>
+            <a:off x="7174125" y="1604701"/>
+            <a:ext cx="806525" cy="617251"/>
+            <a:chOff x="7174125" y="1604701"/>
+            <a:chExt cx="806525" cy="617251"/>
+          </a:xfrm>
+        </p:grpSpPr>
+        <p:pic>
+          <p:nvPicPr>
+            <p:cNvPr id="133" name="Google Shape;133;p17"/>
+            <p:cNvPicPr preferRelativeResize="0"/>
+            <p:nvPr/>
+          </p:nvPicPr>
+          <p:blipFill>
+            <a:blip r:embed="rId11">
+              <a:alphaModFix/>
+            </a:blip>
+            <a:stretch>
+              <a:fillRect/>
+            </a:stretch>
+          </p:blipFill>
+          <p:spPr>
+            <a:xfrm>
+              <a:off x="7174125" y="1604701"/>
+              <a:ext cx="617251" cy="617251"/>
+            </a:xfrm>
+            <a:prstGeom prst="rect">
+              <a:avLst/>
+            </a:prstGeom>
+            <a:noFill/>
+            <a:ln>
+              <a:noFill/>
+            </a:ln>
+          </p:spPr>
+        </p:pic>
+        <p:pic>
+          <p:nvPicPr>
+            <p:cNvPr id="134" name="Google Shape;134;p17"/>
+            <p:cNvPicPr preferRelativeResize="0"/>
+            <p:nvPr/>
+          </p:nvPicPr>
+          <p:blipFill>
+            <a:blip r:embed="rId12">
+              <a:alphaModFix/>
+            </a:blip>
+            <a:stretch>
+              <a:fillRect/>
+            </a:stretch>
+          </p:blipFill>
+          <p:spPr>
+            <a:xfrm>
+              <a:off x="7571375" y="1654936"/>
+              <a:ext cx="409275" cy="409275"/>
+            </a:xfrm>
+            <a:prstGeom prst="rect">
+              <a:avLst/>
+            </a:prstGeom>
+            <a:noFill/>
+            <a:ln>
+              <a:noFill/>
+            </a:ln>
+          </p:spPr>
+        </p:pic>
+      </p:grpSp>
+      <p:grpSp>
+        <p:nvGrpSpPr>
+          <p:cNvPr id="135" name="Google Shape;135;p17"/>
+          <p:cNvGrpSpPr/>
+          <p:nvPr/>
+        </p:nvGrpSpPr>
+        <p:grpSpPr>
+          <a:xfrm>
+            <a:off x="3115300" y="3223375"/>
+            <a:ext cx="788626" cy="676776"/>
+            <a:chOff x="3115300" y="3223375"/>
+            <a:chExt cx="788626" cy="676776"/>
+          </a:xfrm>
+        </p:grpSpPr>
+        <p:pic>
+          <p:nvPicPr>
+            <p:cNvPr id="136" name="Google Shape;136;p17"/>
+            <p:cNvPicPr preferRelativeResize="0"/>
+            <p:nvPr/>
+          </p:nvPicPr>
+          <p:blipFill>
+            <a:blip r:embed="rId13">
+              <a:alphaModFix/>
+            </a:blip>
+            <a:stretch>
+              <a:fillRect/>
+            </a:stretch>
+          </p:blipFill>
+          <p:spPr>
+            <a:xfrm>
+              <a:off x="3115300" y="3223375"/>
+              <a:ext cx="617275" cy="617275"/>
+            </a:xfrm>
+            <a:prstGeom prst="rect">
+              <a:avLst/>
+            </a:prstGeom>
+            <a:noFill/>
+            <a:ln>
+              <a:noFill/>
+            </a:ln>
+          </p:spPr>
+        </p:pic>
+        <p:pic>
+          <p:nvPicPr>
+            <p:cNvPr id="137" name="Google Shape;137;p17"/>
+            <p:cNvPicPr preferRelativeResize="0"/>
+            <p:nvPr/>
+          </p:nvPicPr>
+          <p:blipFill>
+            <a:blip r:embed="rId14">
+              <a:alphaModFix/>
+            </a:blip>
+            <a:stretch>
+              <a:fillRect/>
+            </a:stretch>
+          </p:blipFill>
+          <p:spPr>
+            <a:xfrm>
+              <a:off x="3443100" y="3439326"/>
+              <a:ext cx="460826" cy="460826"/>
+            </a:xfrm>
+            <a:prstGeom prst="rect">
+              <a:avLst/>
+            </a:prstGeom>
+            <a:noFill/>
+            <a:ln>
+              <a:noFill/>
+            </a:ln>
+          </p:spPr>
+        </p:pic>
+      </p:grpSp>
     </p:spTree>
   </p:cSld>
   <p:clrMapOvr>
@@ -11644,7 +12707,7 @@
   <p:cSld>
     <p:spTree>
       <p:nvGrpSpPr>
-        <p:cNvPr id="134" name="Shape 134"/>
+        <p:cNvPr id="141" name="Shape 141"/>
         <p:cNvGrpSpPr/>
         <p:nvPr/>
       </p:nvGrpSpPr>
@@ -11658,7 +12721,7 @@
       </p:grpSpPr>
       <p:sp>
         <p:nvSpPr>
-          <p:cNvPr id="135" name="Google Shape;135;p18"/>
+          <p:cNvPr id="142" name="Google Shape;142;p18"/>
           <p:cNvSpPr txBox="1"/>
           <p:nvPr>
             <p:ph type="title"/>
@@ -11666,7 +12729,7 @@
         </p:nvSpPr>
         <p:spPr>
           <a:xfrm>
-            <a:off x="311700" y="410000"/>
+            <a:off x="187075" y="88775"/>
             <a:ext cx="8520600" cy="607800"/>
           </a:xfrm>
           <a:prstGeom prst="rect">
@@ -11698,7 +12761,7 @@
       </p:sp>
       <p:sp>
         <p:nvSpPr>
-          <p:cNvPr id="136" name="Google Shape;136;p18"/>
+          <p:cNvPr id="143" name="Google Shape;143;p18"/>
           <p:cNvSpPr txBox="1"/>
           <p:nvPr>
             <p:ph idx="1" type="body"/>
@@ -11843,7 +12906,7 @@
       </p:sp>
       <p:pic>
         <p:nvPicPr>
-          <p:cNvPr descr="EscuelaIT Duoc UC - Escuela de Informática y Telecomunicaciones Duoc UC - Duoc  UC | LinkedIn" id="137" name="Google Shape;137;p18"/>
+          <p:cNvPr descr="EscuelaIT Duoc UC - Escuela de Informática y Telecomunicaciones Duoc UC - Duoc  UC | LinkedIn" id="144" name="Google Shape;144;p18"/>
           <p:cNvPicPr preferRelativeResize="0"/>
           <p:nvPr/>
         </p:nvPicPr>
@@ -11870,7 +12933,7 @@
       </p:pic>
       <p:pic>
         <p:nvPicPr>
-          <p:cNvPr id="138" name="Google Shape;138;p18"/>
+          <p:cNvPr id="145" name="Google Shape;145;p18"/>
           <p:cNvPicPr preferRelativeResize="0"/>
           <p:nvPr/>
         </p:nvPicPr>
@@ -11898,7 +12961,7 @@
       </p:pic>
       <p:pic>
         <p:nvPicPr>
-          <p:cNvPr id="139" name="Google Shape;139;p18"/>
+          <p:cNvPr id="146" name="Google Shape;146;p18"/>
           <p:cNvPicPr preferRelativeResize="0"/>
           <p:nvPr/>
         </p:nvPicPr>
@@ -11926,7 +12989,7 @@
       </p:pic>
       <p:pic>
         <p:nvPicPr>
-          <p:cNvPr id="140" name="Google Shape;140;p18"/>
+          <p:cNvPr id="147" name="Google Shape;147;p18"/>
           <p:cNvPicPr preferRelativeResize="0"/>
           <p:nvPr/>
         </p:nvPicPr>
@@ -11965,7 +13028,7 @@
   <p:cSld>
     <p:spTree>
       <p:nvGrpSpPr>
-        <p:cNvPr id="144" name="Shape 144"/>
+        <p:cNvPr id="151" name="Shape 151"/>
         <p:cNvGrpSpPr/>
         <p:nvPr/>
       </p:nvGrpSpPr>
@@ -11979,7 +13042,7 @@
       </p:grpSpPr>
       <p:sp>
         <p:nvSpPr>
-          <p:cNvPr id="145" name="Google Shape;145;p19"/>
+          <p:cNvPr id="152" name="Google Shape;152;p19"/>
           <p:cNvSpPr txBox="1"/>
           <p:nvPr>
             <p:ph type="title"/>
@@ -11987,7 +13050,7 @@
         </p:nvSpPr>
         <p:spPr>
           <a:xfrm>
-            <a:off x="76025" y="88775"/>
+            <a:off x="174750" y="88775"/>
             <a:ext cx="8520600" cy="607800"/>
           </a:xfrm>
           <a:prstGeom prst="rect">
@@ -12023,7 +13086,7 @@
       </p:sp>
       <p:pic>
         <p:nvPicPr>
-          <p:cNvPr descr="EscuelaIT Duoc UC - Escuela de Informática y Telecomunicaciones Duoc UC - Duoc  UC | LinkedIn" id="146" name="Google Shape;146;p19"/>
+          <p:cNvPr descr="EscuelaIT Duoc UC - Escuela de Informática y Telecomunicaciones Duoc UC - Duoc  UC | LinkedIn" id="153" name="Google Shape;153;p19"/>
           <p:cNvPicPr preferRelativeResize="0"/>
           <p:nvPr/>
         </p:nvPicPr>
@@ -12050,7 +13113,7 @@
       </p:pic>
       <p:pic>
         <p:nvPicPr>
-          <p:cNvPr id="147" name="Google Shape;147;p19"/>
+          <p:cNvPr id="154" name="Google Shape;154;p19"/>
           <p:cNvPicPr preferRelativeResize="0"/>
           <p:nvPr/>
         </p:nvPicPr>
@@ -12084,7 +13147,7 @@
       </p:pic>
       <p:pic>
         <p:nvPicPr>
-          <p:cNvPr id="148" name="Google Shape;148;p19"/>
+          <p:cNvPr id="155" name="Google Shape;155;p19"/>
           <p:cNvPicPr preferRelativeResize="0"/>
           <p:nvPr/>
         </p:nvPicPr>
@@ -12129,7 +13192,7 @@
   <p:cSld>
     <p:spTree>
       <p:nvGrpSpPr>
-        <p:cNvPr id="152" name="Shape 152"/>
+        <p:cNvPr id="159" name="Shape 159"/>
         <p:cNvGrpSpPr/>
         <p:nvPr/>
       </p:nvGrpSpPr>
@@ -12143,7 +13206,7 @@
       </p:grpSpPr>
       <p:sp>
         <p:nvSpPr>
-          <p:cNvPr id="153" name="Google Shape;153;p20"/>
+          <p:cNvPr id="160" name="Google Shape;160;p20"/>
           <p:cNvSpPr txBox="1"/>
           <p:nvPr>
             <p:ph type="title"/>
@@ -12151,7 +13214,7 @@
         </p:nvSpPr>
         <p:spPr>
           <a:xfrm>
-            <a:off x="76025" y="88775"/>
+            <a:off x="184625" y="88775"/>
             <a:ext cx="8520600" cy="607800"/>
           </a:xfrm>
           <a:prstGeom prst="rect">
@@ -12183,12 +13246,39 @@
       </p:sp>
       <p:pic>
         <p:nvPicPr>
-          <p:cNvPr id="154" name="Google Shape;154;p20"/>
+          <p:cNvPr descr="EscuelaIT Duoc UC - Escuela de Informática y Telecomunicaciones Duoc UC - Duoc  UC | LinkedIn" id="161" name="Google Shape;161;p20"/>
+          <p:cNvPicPr preferRelativeResize="0"/>
+          <p:nvPr/>
+        </p:nvPicPr>
+        <p:blipFill rotWithShape="1">
+          <a:blip r:embed="rId3">
+            <a:alphaModFix/>
+          </a:blip>
+          <a:srcRect b="0" l="0" r="0" t="0"/>
+          <a:stretch/>
+        </p:blipFill>
+        <p:spPr>
+          <a:xfrm>
+            <a:off x="6002602" y="0"/>
+            <a:ext cx="3141406" cy="785352"/>
+          </a:xfrm>
+          <a:prstGeom prst="rect">
+            <a:avLst/>
+          </a:prstGeom>
+          <a:noFill/>
+          <a:ln>
+            <a:noFill/>
+          </a:ln>
+        </p:spPr>
+      </p:pic>
+      <p:pic>
+        <p:nvPicPr>
+          <p:cNvPr id="162" name="Google Shape;162;p20"/>
           <p:cNvPicPr preferRelativeResize="0"/>
           <p:nvPr/>
         </p:nvPicPr>
         <p:blipFill>
-          <a:blip r:embed="rId3">
+          <a:blip r:embed="rId4">
             <a:alphaModFix/>
           </a:blip>
           <a:stretch>
@@ -12197,7 +13287,7 @@
         </p:blipFill>
         <p:spPr>
           <a:xfrm>
-            <a:off x="2522035" y="621775"/>
+            <a:off x="2472685" y="696575"/>
             <a:ext cx="4315980" cy="1999077"/>
           </a:xfrm>
           <a:prstGeom prst="rect">
@@ -12217,12 +13307,12 @@
       </p:pic>
       <p:pic>
         <p:nvPicPr>
-          <p:cNvPr id="155" name="Google Shape;155;p20"/>
+          <p:cNvPr id="163" name="Google Shape;163;p20"/>
           <p:cNvPicPr preferRelativeResize="0"/>
           <p:nvPr/>
         </p:nvPicPr>
         <p:blipFill>
-          <a:blip r:embed="rId4">
+          <a:blip r:embed="rId5">
             <a:alphaModFix/>
           </a:blip>
           <a:stretch>
@@ -12262,7 +13352,7 @@
   <p:cSld>
     <p:spTree>
       <p:nvGrpSpPr>
-        <p:cNvPr id="159" name="Shape 159"/>
+        <p:cNvPr id="167" name="Shape 167"/>
         <p:cNvGrpSpPr/>
         <p:nvPr/>
       </p:nvGrpSpPr>
@@ -12276,7 +13366,7 @@
       </p:grpSpPr>
       <p:sp>
         <p:nvSpPr>
-          <p:cNvPr id="160" name="Google Shape;160;p21"/>
+          <p:cNvPr id="168" name="Google Shape;168;p21"/>
           <p:cNvSpPr txBox="1"/>
           <p:nvPr>
             <p:ph type="title"/>
@@ -12284,7 +13374,7 @@
         </p:nvSpPr>
         <p:spPr>
           <a:xfrm>
-            <a:off x="311700" y="410000"/>
+            <a:off x="183350" y="88775"/>
             <a:ext cx="8520600" cy="607800"/>
           </a:xfrm>
           <a:prstGeom prst="rect">
@@ -12316,7 +13406,7 @@
       </p:sp>
       <p:pic>
         <p:nvPicPr>
-          <p:cNvPr descr="EscuelaIT Duoc UC - Escuela de Informática y Telecomunicaciones Duoc UC - Duoc  UC | LinkedIn" id="161" name="Google Shape;161;p21"/>
+          <p:cNvPr descr="EscuelaIT Duoc UC - Escuela de Informática y Telecomunicaciones Duoc UC - Duoc  UC | LinkedIn" id="169" name="Google Shape;169;p21"/>
           <p:cNvPicPr preferRelativeResize="0"/>
           <p:nvPr/>
         </p:nvPicPr>
@@ -12341,34 +13431,1057 @@
           </a:ln>
         </p:spPr>
       </p:pic>
-      <p:pic>
-        <p:nvPicPr>
-          <p:cNvPr id="162" name="Google Shape;162;p21" title="Captura de pantalla 2025-06-16 a la(s) 6.08.43 p.m..png"/>
-          <p:cNvPicPr preferRelativeResize="0"/>
+      <p:grpSp>
+        <p:nvGrpSpPr>
+          <p:cNvPr id="170" name="Google Shape;170;p21"/>
+          <p:cNvGrpSpPr/>
           <p:nvPr/>
-        </p:nvPicPr>
-        <p:blipFill>
-          <a:blip r:embed="rId4">
-            <a:alphaModFix/>
-          </a:blip>
-          <a:stretch>
-            <a:fillRect/>
-          </a:stretch>
-        </p:blipFill>
-        <p:spPr>
-          <a:xfrm>
-            <a:off x="376800" y="1017800"/>
-            <a:ext cx="8176927" cy="3522001"/>
-          </a:xfrm>
-          <a:prstGeom prst="rect">
-            <a:avLst/>
-          </a:prstGeom>
-          <a:noFill/>
-          <a:ln>
+        </p:nvGrpSpPr>
+        <p:grpSpPr>
+          <a:xfrm>
+            <a:off x="3689700" y="2373075"/>
+            <a:ext cx="2245500" cy="2294400"/>
+            <a:chOff x="3337700" y="2129125"/>
+            <a:chExt cx="2245500" cy="2294400"/>
+          </a:xfrm>
+        </p:grpSpPr>
+        <p:sp>
+          <p:nvSpPr>
+            <p:cNvPr id="171" name="Google Shape;171;p21"/>
+            <p:cNvSpPr/>
+            <p:nvPr/>
+          </p:nvSpPr>
+          <p:spPr>
+            <a:xfrm>
+              <a:off x="3337700" y="2129125"/>
+              <a:ext cx="2245500" cy="2294400"/>
+            </a:xfrm>
+            <a:prstGeom prst="roundRect">
+              <a:avLst>
+                <a:gd fmla="val 16667" name="adj"/>
+              </a:avLst>
+            </a:prstGeom>
             <a:noFill/>
-          </a:ln>
-        </p:spPr>
-      </p:pic>
+            <a:ln cap="flat" cmpd="sng" w="19050">
+              <a:solidFill>
+                <a:schemeClr val="dk1"/>
+              </a:solidFill>
+              <a:prstDash val="solid"/>
+              <a:round/>
+              <a:headEnd len="sm" w="sm" type="none"/>
+              <a:tailEnd len="sm" w="sm" type="none"/>
+            </a:ln>
+          </p:spPr>
+          <p:txBody>
+            <a:bodyPr anchorCtr="0" anchor="t" bIns="91425" lIns="91425" spcFirstLastPara="1" rIns="91425" wrap="square" tIns="91425">
+              <a:noAutofit/>
+            </a:bodyPr>
+            <a:lstStyle/>
+            <a:p>
+              <a:pPr indent="0" lvl="0" marL="0" rtl="0" algn="ctr">
+                <a:spcBef>
+                  <a:spcPts val="0"/>
+                </a:spcBef>
+                <a:spcAft>
+                  <a:spcPts val="0"/>
+                </a:spcAft>
+                <a:buNone/>
+              </a:pPr>
+              <a:r>
+                <a:rPr b="1" lang="es" sz="1300">
+                  <a:latin typeface="Roboto"/>
+                  <a:ea typeface="Roboto"/>
+                  <a:cs typeface="Roboto"/>
+                  <a:sym typeface="Roboto"/>
+                </a:rPr>
+                <a:t>Backend (Elysia + Bun)</a:t>
+              </a:r>
+              <a:endParaRPr b="1" sz="1300">
+                <a:latin typeface="Roboto"/>
+                <a:ea typeface="Roboto"/>
+                <a:cs typeface="Roboto"/>
+                <a:sym typeface="Roboto"/>
+              </a:endParaRPr>
+            </a:p>
+          </p:txBody>
+        </p:sp>
+        <p:pic>
+          <p:nvPicPr>
+            <p:cNvPr id="172" name="Google Shape;172;p21"/>
+            <p:cNvPicPr preferRelativeResize="0"/>
+            <p:nvPr/>
+          </p:nvPicPr>
+          <p:blipFill>
+            <a:blip r:embed="rId4">
+              <a:alphaModFix/>
+            </a:blip>
+            <a:stretch>
+              <a:fillRect/>
+            </a:stretch>
+          </p:blipFill>
+          <p:spPr>
+            <a:xfrm>
+              <a:off x="3689700" y="2774100"/>
+              <a:ext cx="652800" cy="652800"/>
+            </a:xfrm>
+            <a:prstGeom prst="rect">
+              <a:avLst/>
+            </a:prstGeom>
+            <a:noFill/>
+            <a:ln>
+              <a:noFill/>
+            </a:ln>
+          </p:spPr>
+        </p:pic>
+        <p:pic>
+          <p:nvPicPr>
+            <p:cNvPr id="173" name="Google Shape;173;p21"/>
+            <p:cNvPicPr preferRelativeResize="0"/>
+            <p:nvPr/>
+          </p:nvPicPr>
+          <p:blipFill>
+            <a:blip r:embed="rId5">
+              <a:alphaModFix/>
+            </a:blip>
+            <a:stretch>
+              <a:fillRect/>
+            </a:stretch>
+          </p:blipFill>
+          <p:spPr>
+            <a:xfrm>
+              <a:off x="4553663" y="2814490"/>
+              <a:ext cx="652800" cy="572024"/>
+            </a:xfrm>
+            <a:prstGeom prst="rect">
+              <a:avLst/>
+            </a:prstGeom>
+            <a:noFill/>
+            <a:ln>
+              <a:noFill/>
+            </a:ln>
+          </p:spPr>
+        </p:pic>
+        <p:pic>
+          <p:nvPicPr>
+            <p:cNvPr id="174" name="Google Shape;174;p21"/>
+            <p:cNvPicPr preferRelativeResize="0"/>
+            <p:nvPr/>
+          </p:nvPicPr>
+          <p:blipFill>
+            <a:blip r:embed="rId6">
+              <a:alphaModFix/>
+            </a:blip>
+            <a:stretch>
+              <a:fillRect/>
+            </a:stretch>
+          </p:blipFill>
+          <p:spPr>
+            <a:xfrm>
+              <a:off x="3689691" y="3634191"/>
+              <a:ext cx="652800" cy="652800"/>
+            </a:xfrm>
+            <a:prstGeom prst="rect">
+              <a:avLst/>
+            </a:prstGeom>
+            <a:noFill/>
+            <a:ln>
+              <a:noFill/>
+            </a:ln>
+          </p:spPr>
+        </p:pic>
+        <p:pic>
+          <p:nvPicPr>
+            <p:cNvPr id="175" name="Google Shape;175;p21"/>
+            <p:cNvPicPr preferRelativeResize="0"/>
+            <p:nvPr/>
+          </p:nvPicPr>
+          <p:blipFill>
+            <a:blip r:embed="rId7">
+              <a:alphaModFix/>
+            </a:blip>
+            <a:stretch>
+              <a:fillRect/>
+            </a:stretch>
+          </p:blipFill>
+          <p:spPr>
+            <a:xfrm>
+              <a:off x="4553666" y="3634191"/>
+              <a:ext cx="652800" cy="652800"/>
+            </a:xfrm>
+            <a:prstGeom prst="rect">
+              <a:avLst/>
+            </a:prstGeom>
+            <a:noFill/>
+            <a:ln>
+              <a:noFill/>
+            </a:ln>
+          </p:spPr>
+        </p:pic>
+      </p:grpSp>
+      <p:grpSp>
+        <p:nvGrpSpPr>
+          <p:cNvPr id="176" name="Google Shape;176;p21"/>
+          <p:cNvGrpSpPr/>
+          <p:nvPr/>
+        </p:nvGrpSpPr>
+        <p:grpSpPr>
+          <a:xfrm>
+            <a:off x="6829400" y="1563550"/>
+            <a:ext cx="2245500" cy="2294400"/>
+            <a:chOff x="6282425" y="1659550"/>
+            <a:chExt cx="2245500" cy="2294400"/>
+          </a:xfrm>
+        </p:grpSpPr>
+        <p:sp>
+          <p:nvSpPr>
+            <p:cNvPr id="177" name="Google Shape;177;p21"/>
+            <p:cNvSpPr/>
+            <p:nvPr/>
+          </p:nvSpPr>
+          <p:spPr>
+            <a:xfrm>
+              <a:off x="6282425" y="1659550"/>
+              <a:ext cx="2245500" cy="2294400"/>
+            </a:xfrm>
+            <a:prstGeom prst="roundRect">
+              <a:avLst>
+                <a:gd fmla="val 16667" name="adj"/>
+              </a:avLst>
+            </a:prstGeom>
+            <a:noFill/>
+            <a:ln cap="flat" cmpd="sng" w="19050">
+              <a:solidFill>
+                <a:schemeClr val="dk1"/>
+              </a:solidFill>
+              <a:prstDash val="solid"/>
+              <a:round/>
+              <a:headEnd len="sm" w="sm" type="none"/>
+              <a:tailEnd len="sm" w="sm" type="none"/>
+            </a:ln>
+          </p:spPr>
+          <p:txBody>
+            <a:bodyPr anchorCtr="0" anchor="t" bIns="91425" lIns="91425" spcFirstLastPara="1" rIns="91425" wrap="square" tIns="91425">
+              <a:noAutofit/>
+            </a:bodyPr>
+            <a:lstStyle/>
+            <a:p>
+              <a:pPr indent="0" lvl="0" marL="0" rtl="0" algn="ctr">
+                <a:spcBef>
+                  <a:spcPts val="0"/>
+                </a:spcBef>
+                <a:spcAft>
+                  <a:spcPts val="0"/>
+                </a:spcAft>
+                <a:buNone/>
+              </a:pPr>
+              <a:r>
+                <a:rPr b="1" lang="es" sz="1300">
+                  <a:latin typeface="Roboto"/>
+                  <a:ea typeface="Roboto"/>
+                  <a:cs typeface="Roboto"/>
+                  <a:sym typeface="Roboto"/>
+                </a:rPr>
+                <a:t>Base de Datos (PostgreSQL)</a:t>
+              </a:r>
+              <a:endParaRPr b="1" sz="1300">
+                <a:latin typeface="Roboto"/>
+                <a:ea typeface="Roboto"/>
+                <a:cs typeface="Roboto"/>
+                <a:sym typeface="Roboto"/>
+              </a:endParaRPr>
+            </a:p>
+          </p:txBody>
+        </p:sp>
+        <p:pic>
+          <p:nvPicPr>
+            <p:cNvPr id="178" name="Google Shape;178;p21"/>
+            <p:cNvPicPr preferRelativeResize="0"/>
+            <p:nvPr/>
+          </p:nvPicPr>
+          <p:blipFill>
+            <a:blip r:embed="rId8">
+              <a:alphaModFix/>
+            </a:blip>
+            <a:stretch>
+              <a:fillRect/>
+            </a:stretch>
+          </p:blipFill>
+          <p:spPr>
+            <a:xfrm>
+              <a:off x="6658166" y="3197429"/>
+              <a:ext cx="652800" cy="652800"/>
+            </a:xfrm>
+            <a:prstGeom prst="ellipse">
+              <a:avLst/>
+            </a:prstGeom>
+            <a:noFill/>
+            <a:ln>
+              <a:noFill/>
+            </a:ln>
+          </p:spPr>
+        </p:pic>
+        <p:pic>
+          <p:nvPicPr>
+            <p:cNvPr id="179" name="Google Shape;179;p21"/>
+            <p:cNvPicPr preferRelativeResize="0"/>
+            <p:nvPr/>
+          </p:nvPicPr>
+          <p:blipFill>
+            <a:blip r:embed="rId9">
+              <a:alphaModFix/>
+            </a:blip>
+            <a:stretch>
+              <a:fillRect/>
+            </a:stretch>
+          </p:blipFill>
+          <p:spPr>
+            <a:xfrm>
+              <a:off x="7564341" y="3197416"/>
+              <a:ext cx="652800" cy="652800"/>
+            </a:xfrm>
+            <a:prstGeom prst="ellipse">
+              <a:avLst/>
+            </a:prstGeom>
+            <a:noFill/>
+            <a:ln>
+              <a:noFill/>
+            </a:ln>
+          </p:spPr>
+        </p:pic>
+        <p:pic>
+          <p:nvPicPr>
+            <p:cNvPr id="180" name="Google Shape;180;p21"/>
+            <p:cNvPicPr preferRelativeResize="0"/>
+            <p:nvPr/>
+          </p:nvPicPr>
+          <p:blipFill>
+            <a:blip r:embed="rId10">
+              <a:alphaModFix/>
+            </a:blip>
+            <a:stretch>
+              <a:fillRect/>
+            </a:stretch>
+          </p:blipFill>
+          <p:spPr>
+            <a:xfrm>
+              <a:off x="7072800" y="2437250"/>
+              <a:ext cx="652800" cy="652800"/>
+            </a:xfrm>
+            <a:prstGeom prst="rect">
+              <a:avLst/>
+            </a:prstGeom>
+            <a:noFill/>
+            <a:ln>
+              <a:noFill/>
+            </a:ln>
+          </p:spPr>
+        </p:pic>
+      </p:grpSp>
+      <p:grpSp>
+        <p:nvGrpSpPr>
+          <p:cNvPr id="181" name="Google Shape;181;p21"/>
+          <p:cNvGrpSpPr/>
+          <p:nvPr/>
+        </p:nvGrpSpPr>
+        <p:grpSpPr>
+          <a:xfrm>
+            <a:off x="1135425" y="696563"/>
+            <a:ext cx="1764600" cy="1081800"/>
+            <a:chOff x="2899050" y="1605375"/>
+            <a:chExt cx="1764600" cy="1081800"/>
+          </a:xfrm>
+        </p:grpSpPr>
+        <p:sp>
+          <p:nvSpPr>
+            <p:cNvPr id="182" name="Google Shape;182;p21"/>
+            <p:cNvSpPr/>
+            <p:nvPr/>
+          </p:nvSpPr>
+          <p:spPr>
+            <a:xfrm>
+              <a:off x="2929200" y="1605375"/>
+              <a:ext cx="1704300" cy="1081800"/>
+            </a:xfrm>
+            <a:prstGeom prst="roundRect">
+              <a:avLst>
+                <a:gd fmla="val 16667" name="adj"/>
+              </a:avLst>
+            </a:prstGeom>
+            <a:noFill/>
+            <a:ln cap="flat" cmpd="sng" w="19050">
+              <a:solidFill>
+                <a:schemeClr val="dk1"/>
+              </a:solidFill>
+              <a:prstDash val="solid"/>
+              <a:round/>
+              <a:headEnd len="sm" w="sm" type="none"/>
+              <a:tailEnd len="sm" w="sm" type="none"/>
+            </a:ln>
+          </p:spPr>
+          <p:txBody>
+            <a:bodyPr anchorCtr="0" anchor="ctr" bIns="91425" lIns="91425" spcFirstLastPara="1" rIns="91425" wrap="square" tIns="91425">
+              <a:noAutofit/>
+            </a:bodyPr>
+            <a:lstStyle/>
+            <a:p>
+              <a:pPr indent="0" lvl="0" marL="0" rtl="0" algn="ctr">
+                <a:spcBef>
+                  <a:spcPts val="0"/>
+                </a:spcBef>
+                <a:spcAft>
+                  <a:spcPts val="0"/>
+                </a:spcAft>
+                <a:buNone/>
+              </a:pPr>
+              <a:r>
+                <a:t/>
+              </a:r>
+              <a:endParaRPr>
+                <a:latin typeface="Roboto"/>
+                <a:ea typeface="Roboto"/>
+                <a:cs typeface="Roboto"/>
+                <a:sym typeface="Roboto"/>
+              </a:endParaRPr>
+            </a:p>
+          </p:txBody>
+        </p:sp>
+        <p:grpSp>
+          <p:nvGrpSpPr>
+            <p:cNvPr id="183" name="Google Shape;183;p21"/>
+            <p:cNvGrpSpPr/>
+            <p:nvPr/>
+          </p:nvGrpSpPr>
+          <p:grpSpPr>
+            <a:xfrm>
+              <a:off x="2899050" y="1605377"/>
+              <a:ext cx="1764600" cy="986298"/>
+              <a:chOff x="396375" y="1018302"/>
+              <a:chExt cx="1764600" cy="986298"/>
+            </a:xfrm>
+          </p:grpSpPr>
+          <p:pic>
+            <p:nvPicPr>
+              <p:cNvPr id="184" name="Google Shape;184;p21"/>
+              <p:cNvPicPr preferRelativeResize="0"/>
+              <p:nvPr/>
+            </p:nvPicPr>
+            <p:blipFill>
+              <a:blip r:embed="rId11">
+                <a:alphaModFix/>
+              </a:blip>
+              <a:stretch>
+                <a:fillRect/>
+              </a:stretch>
+            </p:blipFill>
+            <p:spPr>
+              <a:xfrm>
+                <a:off x="952268" y="1018302"/>
+                <a:ext cx="652800" cy="652800"/>
+              </a:xfrm>
+              <a:prstGeom prst="rect">
+                <a:avLst/>
+              </a:prstGeom>
+              <a:noFill/>
+              <a:ln>
+                <a:noFill/>
+              </a:ln>
+            </p:spPr>
+          </p:pic>
+          <p:sp>
+            <p:nvSpPr>
+              <p:cNvPr id="185" name="Google Shape;185;p21"/>
+              <p:cNvSpPr txBox="1"/>
+              <p:nvPr/>
+            </p:nvSpPr>
+            <p:spPr>
+              <a:xfrm>
+                <a:off x="396375" y="1599900"/>
+                <a:ext cx="1764600" cy="404700"/>
+              </a:xfrm>
+              <a:prstGeom prst="rect">
+                <a:avLst/>
+              </a:prstGeom>
+              <a:noFill/>
+              <a:ln>
+                <a:noFill/>
+              </a:ln>
+            </p:spPr>
+            <p:txBody>
+              <a:bodyPr anchorCtr="0" anchor="ctr" bIns="91425" lIns="91425" spcFirstLastPara="1" rIns="91425" wrap="square" tIns="91425">
+                <a:noAutofit/>
+              </a:bodyPr>
+              <a:lstStyle/>
+              <a:p>
+                <a:pPr indent="0" lvl="0" marL="0" rtl="0" algn="ctr">
+                  <a:spcBef>
+                    <a:spcPts val="0"/>
+                  </a:spcBef>
+                  <a:spcAft>
+                    <a:spcPts val="0"/>
+                  </a:spcAft>
+                  <a:buNone/>
+                </a:pPr>
+                <a:r>
+                  <a:rPr b="1" lang="es" sz="1100">
+                    <a:solidFill>
+                      <a:schemeClr val="dk2"/>
+                    </a:solidFill>
+                    <a:latin typeface="Roboto"/>
+                    <a:ea typeface="Roboto"/>
+                    <a:cs typeface="Roboto"/>
+                    <a:sym typeface="Roboto"/>
+                  </a:rPr>
+                  <a:t>Usuario Final</a:t>
+                </a:r>
+                <a:endParaRPr b="1" sz="1100">
+                  <a:solidFill>
+                    <a:schemeClr val="dk2"/>
+                  </a:solidFill>
+                  <a:latin typeface="Roboto"/>
+                  <a:ea typeface="Roboto"/>
+                  <a:cs typeface="Roboto"/>
+                  <a:sym typeface="Roboto"/>
+                </a:endParaRPr>
+              </a:p>
+              <a:p>
+                <a:pPr indent="0" lvl="0" marL="0" rtl="0" algn="ctr">
+                  <a:spcBef>
+                    <a:spcPts val="0"/>
+                  </a:spcBef>
+                  <a:spcAft>
+                    <a:spcPts val="0"/>
+                  </a:spcAft>
+                  <a:buNone/>
+                </a:pPr>
+                <a:r>
+                  <a:rPr b="1" lang="es" sz="1100">
+                    <a:solidFill>
+                      <a:schemeClr val="dk2"/>
+                    </a:solidFill>
+                    <a:latin typeface="Roboto"/>
+                    <a:ea typeface="Roboto"/>
+                    <a:cs typeface="Roboto"/>
+                    <a:sym typeface="Roboto"/>
+                  </a:rPr>
+                  <a:t>(Visitante / Registrado)</a:t>
+                </a:r>
+                <a:endParaRPr b="1" sz="1100">
+                  <a:solidFill>
+                    <a:schemeClr val="dk2"/>
+                  </a:solidFill>
+                  <a:latin typeface="Roboto"/>
+                  <a:ea typeface="Roboto"/>
+                  <a:cs typeface="Roboto"/>
+                  <a:sym typeface="Roboto"/>
+                </a:endParaRPr>
+              </a:p>
+            </p:txBody>
+          </p:sp>
+        </p:grpSp>
+      </p:grpSp>
+      <p:grpSp>
+        <p:nvGrpSpPr>
+          <p:cNvPr id="186" name="Google Shape;186;p21"/>
+          <p:cNvGrpSpPr/>
+          <p:nvPr/>
+        </p:nvGrpSpPr>
+        <p:grpSpPr>
+          <a:xfrm>
+            <a:off x="303525" y="2326575"/>
+            <a:ext cx="2596500" cy="2387400"/>
+            <a:chOff x="283775" y="2085325"/>
+            <a:chExt cx="2596500" cy="2387400"/>
+          </a:xfrm>
+        </p:grpSpPr>
+        <p:pic>
+          <p:nvPicPr>
+            <p:cNvPr id="187" name="Google Shape;187;p21"/>
+            <p:cNvPicPr preferRelativeResize="0"/>
+            <p:nvPr/>
+          </p:nvPicPr>
+          <p:blipFill>
+            <a:blip r:embed="rId12">
+              <a:alphaModFix/>
+            </a:blip>
+            <a:stretch>
+              <a:fillRect/>
+            </a:stretch>
+          </p:blipFill>
+          <p:spPr>
+            <a:xfrm>
+              <a:off x="476700" y="2774100"/>
+              <a:ext cx="652800" cy="652800"/>
+            </a:xfrm>
+            <a:prstGeom prst="rect">
+              <a:avLst/>
+            </a:prstGeom>
+            <a:noFill/>
+            <a:ln>
+              <a:noFill/>
+            </a:ln>
+          </p:spPr>
+        </p:pic>
+        <p:pic>
+          <p:nvPicPr>
+            <p:cNvPr id="188" name="Google Shape;188;p21"/>
+            <p:cNvPicPr preferRelativeResize="0"/>
+            <p:nvPr/>
+          </p:nvPicPr>
+          <p:blipFill>
+            <a:blip r:embed="rId13">
+              <a:alphaModFix/>
+            </a:blip>
+            <a:stretch>
+              <a:fillRect/>
+            </a:stretch>
+          </p:blipFill>
+          <p:spPr>
+            <a:xfrm>
+              <a:off x="1255616" y="2774091"/>
+              <a:ext cx="652800" cy="652800"/>
+            </a:xfrm>
+            <a:prstGeom prst="rect">
+              <a:avLst/>
+            </a:prstGeom>
+            <a:noFill/>
+            <a:ln>
+              <a:noFill/>
+            </a:ln>
+          </p:spPr>
+        </p:pic>
+        <p:pic>
+          <p:nvPicPr>
+            <p:cNvPr id="189" name="Google Shape;189;p21"/>
+            <p:cNvPicPr preferRelativeResize="0"/>
+            <p:nvPr/>
+          </p:nvPicPr>
+          <p:blipFill>
+            <a:blip r:embed="rId14">
+              <a:alphaModFix/>
+            </a:blip>
+            <a:stretch>
+              <a:fillRect/>
+            </a:stretch>
+          </p:blipFill>
+          <p:spPr>
+            <a:xfrm>
+              <a:off x="2034550" y="2778441"/>
+              <a:ext cx="652800" cy="644100"/>
+            </a:xfrm>
+            <a:prstGeom prst="ellipse">
+              <a:avLst/>
+            </a:prstGeom>
+            <a:noFill/>
+            <a:ln>
+              <a:noFill/>
+            </a:ln>
+          </p:spPr>
+        </p:pic>
+        <p:pic>
+          <p:nvPicPr>
+            <p:cNvPr id="190" name="Google Shape;190;p21"/>
+            <p:cNvPicPr preferRelativeResize="0"/>
+            <p:nvPr/>
+          </p:nvPicPr>
+          <p:blipFill>
+            <a:blip r:embed="rId15">
+              <a:alphaModFix/>
+            </a:blip>
+            <a:stretch>
+              <a:fillRect/>
+            </a:stretch>
+          </p:blipFill>
+          <p:spPr>
+            <a:xfrm>
+              <a:off x="760525" y="3593500"/>
+              <a:ext cx="652800" cy="652800"/>
+            </a:xfrm>
+            <a:prstGeom prst="ellipse">
+              <a:avLst/>
+            </a:prstGeom>
+            <a:noFill/>
+            <a:ln>
+              <a:noFill/>
+            </a:ln>
+          </p:spPr>
+        </p:pic>
+        <p:pic>
+          <p:nvPicPr>
+            <p:cNvPr id="191" name="Google Shape;191;p21"/>
+            <p:cNvPicPr preferRelativeResize="0"/>
+            <p:nvPr/>
+          </p:nvPicPr>
+          <p:blipFill>
+            <a:blip r:embed="rId16">
+              <a:alphaModFix/>
+            </a:blip>
+            <a:stretch>
+              <a:fillRect/>
+            </a:stretch>
+          </p:blipFill>
+          <p:spPr>
+            <a:xfrm>
+              <a:off x="1657516" y="3593491"/>
+              <a:ext cx="652800" cy="652800"/>
+            </a:xfrm>
+            <a:prstGeom prst="ellipse">
+              <a:avLst/>
+            </a:prstGeom>
+            <a:noFill/>
+            <a:ln>
+              <a:noFill/>
+            </a:ln>
+          </p:spPr>
+        </p:pic>
+        <p:sp>
+          <p:nvSpPr>
+            <p:cNvPr id="192" name="Google Shape;192;p21"/>
+            <p:cNvSpPr/>
+            <p:nvPr/>
+          </p:nvSpPr>
+          <p:spPr>
+            <a:xfrm>
+              <a:off x="283775" y="2085325"/>
+              <a:ext cx="2596500" cy="2387400"/>
+            </a:xfrm>
+            <a:prstGeom prst="roundRect">
+              <a:avLst>
+                <a:gd fmla="val 16667" name="adj"/>
+              </a:avLst>
+            </a:prstGeom>
+            <a:noFill/>
+            <a:ln cap="flat" cmpd="sng" w="19050">
+              <a:solidFill>
+                <a:schemeClr val="dk1"/>
+              </a:solidFill>
+              <a:prstDash val="solid"/>
+              <a:round/>
+              <a:headEnd len="sm" w="sm" type="none"/>
+              <a:tailEnd len="sm" w="sm" type="none"/>
+            </a:ln>
+          </p:spPr>
+          <p:txBody>
+            <a:bodyPr anchorCtr="0" anchor="t" bIns="91425" lIns="91425" spcFirstLastPara="1" rIns="91425" wrap="square" tIns="91425">
+              <a:noAutofit/>
+            </a:bodyPr>
+            <a:lstStyle/>
+            <a:p>
+              <a:pPr indent="0" lvl="0" marL="0" rtl="0" algn="ctr">
+                <a:spcBef>
+                  <a:spcPts val="0"/>
+                </a:spcBef>
+                <a:spcAft>
+                  <a:spcPts val="0"/>
+                </a:spcAft>
+                <a:buNone/>
+              </a:pPr>
+              <a:r>
+                <a:rPr b="1" lang="es" sz="1300">
+                  <a:latin typeface="Roboto"/>
+                  <a:ea typeface="Roboto"/>
+                  <a:cs typeface="Roboto"/>
+                  <a:sym typeface="Roboto"/>
+                </a:rPr>
+                <a:t>Frontend (Next.js + Tailwind)</a:t>
+              </a:r>
+              <a:endParaRPr b="1" sz="1300">
+                <a:latin typeface="Roboto"/>
+                <a:ea typeface="Roboto"/>
+                <a:cs typeface="Roboto"/>
+                <a:sym typeface="Roboto"/>
+              </a:endParaRPr>
+            </a:p>
+          </p:txBody>
+        </p:sp>
+      </p:grpSp>
+      <p:grpSp>
+        <p:nvGrpSpPr>
+          <p:cNvPr id="193" name="Google Shape;193;p21"/>
+          <p:cNvGrpSpPr/>
+          <p:nvPr/>
+        </p:nvGrpSpPr>
+        <p:grpSpPr>
+          <a:xfrm>
+            <a:off x="5859598" y="2486563"/>
+            <a:ext cx="1038900" cy="1033712"/>
+            <a:chOff x="5859598" y="2486563"/>
+            <a:chExt cx="1038900" cy="1033712"/>
+          </a:xfrm>
+        </p:grpSpPr>
+        <p:cxnSp>
+          <p:nvCxnSpPr>
+            <p:cNvPr id="194" name="Google Shape;194;p21"/>
+            <p:cNvCxnSpPr>
+              <a:stCxn id="171" idx="3"/>
+              <a:endCxn id="177" idx="1"/>
+            </p:cNvCxnSpPr>
+            <p:nvPr/>
+          </p:nvCxnSpPr>
+          <p:spPr>
+            <a:xfrm flipH="1" rot="10800000">
+              <a:off x="5935200" y="2710875"/>
+              <a:ext cx="894300" cy="809400"/>
+            </a:xfrm>
+            <a:prstGeom prst="straightConnector1">
+              <a:avLst/>
+            </a:prstGeom>
+            <a:noFill/>
+            <a:ln cap="flat" cmpd="sng" w="28575">
+              <a:solidFill>
+                <a:schemeClr val="dk1"/>
+              </a:solidFill>
+              <a:prstDash val="solid"/>
+              <a:round/>
+              <a:headEnd len="med" w="med" type="none"/>
+              <a:tailEnd len="med" w="med" type="triangle"/>
+            </a:ln>
+          </p:spPr>
+        </p:cxnSp>
+        <p:sp>
+          <p:nvSpPr>
+            <p:cNvPr id="195" name="Google Shape;195;p21"/>
+            <p:cNvSpPr txBox="1"/>
+            <p:nvPr/>
+          </p:nvSpPr>
+          <p:spPr>
+            <a:xfrm rot="-2267637">
+              <a:off x="5876783" y="2752427"/>
+              <a:ext cx="1004531" cy="400071"/>
+            </a:xfrm>
+            <a:prstGeom prst="rect">
+              <a:avLst/>
+            </a:prstGeom>
+            <a:noFill/>
+            <a:ln>
+              <a:noFill/>
+            </a:ln>
+          </p:spPr>
+          <p:txBody>
+            <a:bodyPr anchorCtr="0" anchor="ctr" bIns="91425" lIns="91425" spcFirstLastPara="1" rIns="91425" wrap="square" tIns="91425">
+              <a:noAutofit/>
+            </a:bodyPr>
+            <a:lstStyle/>
+            <a:p>
+              <a:pPr indent="0" lvl="0" marL="0" rtl="0" algn="ctr">
+                <a:spcBef>
+                  <a:spcPts val="0"/>
+                </a:spcBef>
+                <a:spcAft>
+                  <a:spcPts val="0"/>
+                </a:spcAft>
+                <a:buNone/>
+              </a:pPr>
+              <a:r>
+                <a:rPr lang="es" sz="1100">
+                  <a:latin typeface="Roboto"/>
+                  <a:ea typeface="Roboto"/>
+                  <a:cs typeface="Roboto"/>
+                  <a:sym typeface="Roboto"/>
+                </a:rPr>
+                <a:t>Drizzle ORM</a:t>
+              </a:r>
+              <a:endParaRPr sz="1100">
+                <a:latin typeface="Roboto"/>
+                <a:ea typeface="Roboto"/>
+                <a:cs typeface="Roboto"/>
+                <a:sym typeface="Roboto"/>
+              </a:endParaRPr>
+            </a:p>
+          </p:txBody>
+        </p:sp>
+      </p:grpSp>
+      <p:grpSp>
+        <p:nvGrpSpPr>
+          <p:cNvPr id="196" name="Google Shape;196;p21"/>
+          <p:cNvGrpSpPr/>
+          <p:nvPr/>
+        </p:nvGrpSpPr>
+        <p:grpSpPr>
+          <a:xfrm>
+            <a:off x="2900025" y="3181375"/>
+            <a:ext cx="789600" cy="400200"/>
+            <a:chOff x="2900025" y="3181375"/>
+            <a:chExt cx="789600" cy="400200"/>
+          </a:xfrm>
+        </p:grpSpPr>
+        <p:cxnSp>
+          <p:nvCxnSpPr>
+            <p:cNvPr id="197" name="Google Shape;197;p21"/>
+            <p:cNvCxnSpPr>
+              <a:stCxn id="192" idx="3"/>
+              <a:endCxn id="171" idx="1"/>
+            </p:cNvCxnSpPr>
+            <p:nvPr/>
+          </p:nvCxnSpPr>
+          <p:spPr>
+            <a:xfrm>
+              <a:off x="2900025" y="3520275"/>
+              <a:ext cx="789600" cy="0"/>
+            </a:xfrm>
+            <a:prstGeom prst="straightConnector1">
+              <a:avLst/>
+            </a:prstGeom>
+            <a:noFill/>
+            <a:ln cap="flat" cmpd="sng" w="28575">
+              <a:solidFill>
+                <a:schemeClr val="dk1"/>
+              </a:solidFill>
+              <a:prstDash val="solid"/>
+              <a:round/>
+              <a:headEnd len="med" w="med" type="none"/>
+              <a:tailEnd len="med" w="med" type="triangle"/>
+            </a:ln>
+          </p:spPr>
+        </p:cxnSp>
+        <p:sp>
+          <p:nvSpPr>
+            <p:cNvPr id="198" name="Google Shape;198;p21"/>
+            <p:cNvSpPr txBox="1"/>
+            <p:nvPr/>
+          </p:nvSpPr>
+          <p:spPr>
+            <a:xfrm>
+              <a:off x="2986799" y="3181375"/>
+              <a:ext cx="525000" cy="400200"/>
+            </a:xfrm>
+            <a:prstGeom prst="rect">
+              <a:avLst/>
+            </a:prstGeom>
+            <a:noFill/>
+            <a:ln>
+              <a:noFill/>
+            </a:ln>
+          </p:spPr>
+          <p:txBody>
+            <a:bodyPr anchorCtr="0" anchor="ctr" bIns="91425" lIns="91425" spcFirstLastPara="1" rIns="91425" wrap="square" tIns="91425">
+              <a:noAutofit/>
+            </a:bodyPr>
+            <a:lstStyle/>
+            <a:p>
+              <a:pPr indent="0" lvl="0" marL="0" rtl="0" algn="ctr">
+                <a:spcBef>
+                  <a:spcPts val="0"/>
+                </a:spcBef>
+                <a:spcAft>
+                  <a:spcPts val="0"/>
+                </a:spcAft>
+                <a:buNone/>
+              </a:pPr>
+              <a:r>
+                <a:rPr lang="es" sz="1100">
+                  <a:latin typeface="Roboto"/>
+                  <a:ea typeface="Roboto"/>
+                  <a:cs typeface="Roboto"/>
+                  <a:sym typeface="Roboto"/>
+                </a:rPr>
+                <a:t>JWT</a:t>
+              </a:r>
+              <a:endParaRPr sz="1100">
+                <a:latin typeface="Roboto"/>
+                <a:ea typeface="Roboto"/>
+                <a:cs typeface="Roboto"/>
+                <a:sym typeface="Roboto"/>
+              </a:endParaRPr>
+            </a:p>
+          </p:txBody>
+        </p:sp>
+      </p:grpSp>
+      <p:grpSp>
+        <p:nvGrpSpPr>
+          <p:cNvPr id="199" name="Google Shape;199;p21"/>
+          <p:cNvGrpSpPr/>
+          <p:nvPr/>
+        </p:nvGrpSpPr>
+        <p:grpSpPr>
+          <a:xfrm>
+            <a:off x="1601925" y="1778363"/>
+            <a:ext cx="1298101" cy="548100"/>
+            <a:chOff x="1601925" y="1778363"/>
+            <a:chExt cx="1298101" cy="548100"/>
+          </a:xfrm>
+        </p:grpSpPr>
+        <p:cxnSp>
+          <p:nvCxnSpPr>
+            <p:cNvPr id="200" name="Google Shape;200;p21"/>
+            <p:cNvCxnSpPr>
+              <a:stCxn id="182" idx="2"/>
+              <a:endCxn id="192" idx="0"/>
+            </p:cNvCxnSpPr>
+            <p:nvPr/>
+          </p:nvCxnSpPr>
+          <p:spPr>
+            <a:xfrm flipH="1">
+              <a:off x="1601925" y="1778363"/>
+              <a:ext cx="415800" cy="548100"/>
+            </a:xfrm>
+            <a:prstGeom prst="straightConnector1">
+              <a:avLst/>
+            </a:prstGeom>
+            <a:noFill/>
+            <a:ln cap="flat" cmpd="sng" w="28575">
+              <a:solidFill>
+                <a:schemeClr val="dk1"/>
+              </a:solidFill>
+              <a:prstDash val="solid"/>
+              <a:round/>
+              <a:headEnd len="med" w="med" type="none"/>
+              <a:tailEnd len="med" w="med" type="triangle"/>
+            </a:ln>
+          </p:spPr>
+        </p:cxnSp>
+        <p:sp>
+          <p:nvSpPr>
+            <p:cNvPr id="201" name="Google Shape;201;p21"/>
+            <p:cNvSpPr txBox="1"/>
+            <p:nvPr/>
+          </p:nvSpPr>
+          <p:spPr>
+            <a:xfrm>
+              <a:off x="1793926" y="1852375"/>
+              <a:ext cx="1106100" cy="400200"/>
+            </a:xfrm>
+            <a:prstGeom prst="rect">
+              <a:avLst/>
+            </a:prstGeom>
+            <a:noFill/>
+            <a:ln>
+              <a:noFill/>
+            </a:ln>
+          </p:spPr>
+          <p:txBody>
+            <a:bodyPr anchorCtr="0" anchor="ctr" bIns="91425" lIns="91425" spcFirstLastPara="1" rIns="91425" wrap="square" tIns="91425">
+              <a:noAutofit/>
+            </a:bodyPr>
+            <a:lstStyle/>
+            <a:p>
+              <a:pPr indent="0" lvl="0" marL="0" rtl="0" algn="ctr">
+                <a:spcBef>
+                  <a:spcPts val="0"/>
+                </a:spcBef>
+                <a:spcAft>
+                  <a:spcPts val="0"/>
+                </a:spcAft>
+                <a:buNone/>
+              </a:pPr>
+              <a:r>
+                <a:rPr lang="es" sz="1100">
+                  <a:latin typeface="Roboto"/>
+                  <a:ea typeface="Roboto"/>
+                  <a:cs typeface="Roboto"/>
+                  <a:sym typeface="Roboto"/>
+                </a:rPr>
+                <a:t>Usa interfaz web</a:t>
+              </a:r>
+              <a:endParaRPr sz="1100">
+                <a:latin typeface="Roboto"/>
+                <a:ea typeface="Roboto"/>
+                <a:cs typeface="Roboto"/>
+                <a:sym typeface="Roboto"/>
+              </a:endParaRPr>
+            </a:p>
+          </p:txBody>
+        </p:sp>
+      </p:grpSp>
     </p:spTree>
   </p:cSld>
   <p:clrMapOvr>
@@ -12378,6 +14491,285 @@
 </file>
 
 <file path=ppt/theme/theme1.xml><?xml version="1.0" encoding="utf-8"?>
+<a:theme xmlns:a="http://schemas.openxmlformats.org/drawingml/2006/main" xmlns:r="http://schemas.openxmlformats.org/officeDocument/2006/relationships" name="Geometric">
+  <a:themeElements>
+    <a:clrScheme name="Geometric">
+      <a:dk1>
+        <a:srgbClr val="2A3990"/>
+      </a:dk1>
+      <a:lt1>
+        <a:srgbClr val="FFFFFF"/>
+      </a:lt1>
+      <a:dk2>
+        <a:srgbClr val="434343"/>
+      </a:dk2>
+      <a:lt2>
+        <a:srgbClr val="999999"/>
+      </a:lt2>
+      <a:accent1>
+        <a:srgbClr val="212D74"/>
+      </a:accent1>
+      <a:accent2>
+        <a:srgbClr val="3949AB"/>
+      </a:accent2>
+      <a:accent3>
+        <a:srgbClr val="9C254D"/>
+      </a:accent3>
+      <a:accent4>
+        <a:srgbClr val="D23369"/>
+      </a:accent4>
+      <a:accent5>
+        <a:srgbClr val="F06292"/>
+      </a:accent5>
+      <a:accent6>
+        <a:srgbClr val="7890CD"/>
+      </a:accent6>
+      <a:hlink>
+        <a:srgbClr val="F06292"/>
+      </a:hlink>
+      <a:folHlink>
+        <a:srgbClr val="F06292"/>
+      </a:folHlink>
+    </a:clrScheme>
+    <a:fontScheme name="Office">
+      <a:majorFont>
+        <a:latin typeface="Arial"/>
+        <a:ea typeface=""/>
+        <a:cs typeface=""/>
+        <a:font script="Jpan" typeface="ＭＳ Ｐゴシック"/>
+        <a:font script="Hang" typeface="맑은 고딕"/>
+        <a:font script="Hans" typeface="宋体"/>
+        <a:font script="Hant" typeface="新細明體"/>
+        <a:font script="Arab" typeface="Times New Roman"/>
+        <a:font script="Hebr" typeface="Times New Roman"/>
+        <a:font script="Thai" typeface="Angsana New"/>
+        <a:font script="Ethi" typeface="Nyala"/>
+        <a:font script="Beng" typeface="Vrinda"/>
+        <a:font script="Gujr" typeface="Shruti"/>
+        <a:font script="Khmr" typeface="MoolBoran"/>
+        <a:font script="Knda" typeface="Tunga"/>
+        <a:font script="Guru" typeface="Raavi"/>
+        <a:font script="Cans" typeface="Euphemia"/>
+        <a:font script="Cher" typeface="Plantagenet Cherokee"/>
+        <a:font script="Yiii" typeface="Microsoft Yi Baiti"/>
+        <a:font script="Tibt" typeface="Microsoft Himalaya"/>
+        <a:font script="Thaa" typeface="MV Boli"/>
+        <a:font script="Deva" typeface="Mangal"/>
+        <a:font script="Telu" typeface="Gautami"/>
+        <a:font script="Taml" typeface="Latha"/>
+        <a:font script="Syrc" typeface="Estrangelo Edessa"/>
+        <a:font script="Orya" typeface="Kalinga"/>
+        <a:font script="Mlym" typeface="Kartika"/>
+        <a:font script="Laoo" typeface="DokChampa"/>
+        <a:font script="Sinh" typeface="Iskoola Pota"/>
+        <a:font script="Mong" typeface="Mongolian Baiti"/>
+        <a:font script="Viet" typeface="Times New Roman"/>
+        <a:font script="Uigh" typeface="Microsoft Uighur"/>
+        <a:font script="Geor" typeface="Sylfaen"/>
+      </a:majorFont>
+      <a:minorFont>
+        <a:latin typeface="Arial"/>
+        <a:ea typeface=""/>
+        <a:cs typeface=""/>
+        <a:font script="Jpan" typeface="ＭＳ Ｐゴシック"/>
+        <a:font script="Hang" typeface="맑은 고딕"/>
+        <a:font script="Hans" typeface="宋体"/>
+        <a:font script="Hant" typeface="新細明體"/>
+        <a:font script="Arab" typeface="Arial"/>
+        <a:font script="Hebr" typeface="Arial"/>
+        <a:font script="Thai" typeface="Cordia New"/>
+        <a:font script="Ethi" typeface="Nyala"/>
+        <a:font script="Beng" typeface="Vrinda"/>
+        <a:font script="Gujr" typeface="Shruti"/>
+        <a:font script="Khmr" typeface="DaunPenh"/>
+        <a:font script="Knda" typeface="Tunga"/>
+        <a:font script="Guru" typeface="Raavi"/>
+        <a:font script="Cans" typeface="Euphemia"/>
+        <a:font script="Cher" typeface="Plantagenet Cherokee"/>
+        <a:font script="Yiii" typeface="Microsoft Yi Baiti"/>
+        <a:font script="Tibt" typeface="Microsoft Himalaya"/>
+        <a:font script="Thaa" typeface="MV Boli"/>
+        <a:font script="Deva" typeface="Mangal"/>
+        <a:font script="Telu" typeface="Gautami"/>
+        <a:font script="Taml" typeface="Latha"/>
+        <a:font script="Syrc" typeface="Estrangelo Edessa"/>
+        <a:font script="Orya" typeface="Kalinga"/>
+        <a:font script="Mlym" typeface="Kartika"/>
+        <a:font script="Laoo" typeface="DokChampa"/>
+        <a:font script="Sinh" typeface="Iskoola Pota"/>
+        <a:font script="Mong" typeface="Mongolian Baiti"/>
+        <a:font script="Viet" typeface="Arial"/>
+        <a:font script="Uigh" typeface="Microsoft Uighur"/>
+        <a:font script="Geor" typeface="Sylfaen"/>
+      </a:minorFont>
+    </a:fontScheme>
+    <a:fmtScheme name="Office">
+      <a:fillStyleLst>
+        <a:solidFill>
+          <a:schemeClr val="phClr"/>
+        </a:solidFill>
+        <a:gradFill rotWithShape="1">
+          <a:gsLst>
+            <a:gs pos="0">
+              <a:schemeClr val="phClr">
+                <a:tint val="50000"/>
+                <a:satMod val="300000"/>
+              </a:schemeClr>
+            </a:gs>
+            <a:gs pos="35000">
+              <a:schemeClr val="phClr">
+                <a:tint val="37000"/>
+                <a:satMod val="300000"/>
+              </a:schemeClr>
+            </a:gs>
+            <a:gs pos="100000">
+              <a:schemeClr val="phClr">
+                <a:tint val="15000"/>
+                <a:satMod val="350000"/>
+              </a:schemeClr>
+            </a:gs>
+          </a:gsLst>
+          <a:lin ang="16200000" scaled="1"/>
+        </a:gradFill>
+        <a:gradFill rotWithShape="1">
+          <a:gsLst>
+            <a:gs pos="0">
+              <a:schemeClr val="phClr">
+                <a:tint val="100000"/>
+                <a:shade val="100000"/>
+                <a:satMod val="130000"/>
+              </a:schemeClr>
+            </a:gs>
+            <a:gs pos="100000">
+              <a:schemeClr val="phClr">
+                <a:tint val="50000"/>
+                <a:shade val="100000"/>
+                <a:satMod val="350000"/>
+              </a:schemeClr>
+            </a:gs>
+          </a:gsLst>
+          <a:lin ang="16200000" scaled="0"/>
+        </a:gradFill>
+      </a:fillStyleLst>
+      <a:lnStyleLst>
+        <a:ln w="9525" cap="flat" cmpd="sng" algn="ctr">
+          <a:solidFill>
+            <a:schemeClr val="phClr">
+              <a:shade val="95000"/>
+              <a:satMod val="105000"/>
+            </a:schemeClr>
+          </a:solidFill>
+          <a:prstDash val="solid"/>
+        </a:ln>
+        <a:ln w="25400" cap="flat" cmpd="sng" algn="ctr">
+          <a:solidFill>
+            <a:schemeClr val="phClr"/>
+          </a:solidFill>
+          <a:prstDash val="solid"/>
+        </a:ln>
+        <a:ln w="38100" cap="flat" cmpd="sng" algn="ctr">
+          <a:solidFill>
+            <a:schemeClr val="phClr"/>
+          </a:solidFill>
+          <a:prstDash val="solid"/>
+        </a:ln>
+      </a:lnStyleLst>
+      <a:effectStyleLst>
+        <a:effectStyle>
+          <a:effectLst>
+            <a:outerShdw blurRad="40000" dist="20000" dir="5400000" rotWithShape="0">
+              <a:srgbClr val="000000">
+                <a:alpha val="38000"/>
+              </a:srgbClr>
+            </a:outerShdw>
+          </a:effectLst>
+        </a:effectStyle>
+        <a:effectStyle>
+          <a:effectLst>
+            <a:outerShdw blurRad="40000" dist="23000" dir="5400000" rotWithShape="0">
+              <a:srgbClr val="000000">
+                <a:alpha val="35000"/>
+              </a:srgbClr>
+            </a:outerShdw>
+          </a:effectLst>
+        </a:effectStyle>
+        <a:effectStyle>
+          <a:effectLst>
+            <a:outerShdw blurRad="40000" dist="23000" dir="5400000" rotWithShape="0">
+              <a:srgbClr val="000000">
+                <a:alpha val="35000"/>
+              </a:srgbClr>
+            </a:outerShdw>
+          </a:effectLst>
+          <a:scene3d>
+            <a:camera prst="orthographicFront">
+              <a:rot lat="0" lon="0" rev="0"/>
+            </a:camera>
+            <a:lightRig rig="threePt" dir="t">
+              <a:rot lat="0" lon="0" rev="1200000"/>
+            </a:lightRig>
+          </a:scene3d>
+          <a:sp3d>
+            <a:bevelT w="63500" h="25400"/>
+          </a:sp3d>
+        </a:effectStyle>
+      </a:effectStyleLst>
+      <a:bgFillStyleLst>
+        <a:solidFill>
+          <a:schemeClr val="phClr"/>
+        </a:solidFill>
+        <a:gradFill rotWithShape="1">
+          <a:gsLst>
+            <a:gs pos="0">
+              <a:schemeClr val="phClr">
+                <a:tint val="40000"/>
+                <a:satMod val="350000"/>
+              </a:schemeClr>
+            </a:gs>
+            <a:gs pos="40000">
+              <a:schemeClr val="phClr">
+                <a:tint val="45000"/>
+                <a:shade val="99000"/>
+                <a:satMod val="350000"/>
+              </a:schemeClr>
+            </a:gs>
+            <a:gs pos="100000">
+              <a:schemeClr val="phClr">
+                <a:shade val="20000"/>
+                <a:satMod val="255000"/>
+              </a:schemeClr>
+            </a:gs>
+          </a:gsLst>
+          <a:path path="circle">
+            <a:fillToRect l="50000" t="-80000" r="50000" b="180000"/>
+          </a:path>
+        </a:gradFill>
+        <a:gradFill rotWithShape="1">
+          <a:gsLst>
+            <a:gs pos="0">
+              <a:schemeClr val="phClr">
+                <a:tint val="80000"/>
+                <a:satMod val="300000"/>
+              </a:schemeClr>
+            </a:gs>
+            <a:gs pos="100000">
+              <a:schemeClr val="phClr">
+                <a:shade val="30000"/>
+                <a:satMod val="200000"/>
+              </a:schemeClr>
+            </a:gs>
+          </a:gsLst>
+          <a:path path="circle">
+            <a:fillToRect l="50000" t="50000" r="50000" b="50000"/>
+          </a:path>
+        </a:gradFill>
+      </a:bgFillStyleLst>
+    </a:fmtScheme>
+  </a:themeElements>
+</a:theme>
+</file>
+
+<file path=ppt/theme/theme2.xml><?xml version="1.0" encoding="utf-8"?>
 <a:theme xmlns:a="http://schemas.openxmlformats.org/drawingml/2006/main" xmlns:r="http://schemas.openxmlformats.org/officeDocument/2006/relationships">
   <a:themeElements>
     <a:clrScheme name="Default">
@@ -12654,283 +15046,4 @@
     </a:fmtScheme>
   </a:themeElements>
 </a:theme>
-</file>
-
-<file path=ppt/theme/theme2.xml><?xml version="1.0" encoding="utf-8"?>
-<a:theme xmlns:a="http://schemas.openxmlformats.org/drawingml/2006/main" xmlns:r="http://schemas.openxmlformats.org/officeDocument/2006/relationships" name="Geometric">
-  <a:themeElements>
-    <a:clrScheme name="Geometric">
-      <a:dk1>
-        <a:srgbClr val="2A3990"/>
-      </a:dk1>
-      <a:lt1>
-        <a:srgbClr val="FFFFFF"/>
-      </a:lt1>
-      <a:dk2>
-        <a:srgbClr val="434343"/>
-      </a:dk2>
-      <a:lt2>
-        <a:srgbClr val="999999"/>
-      </a:lt2>
-      <a:accent1>
-        <a:srgbClr val="212D74"/>
-      </a:accent1>
-      <a:accent2>
-        <a:srgbClr val="3949AB"/>
-      </a:accent2>
-      <a:accent3>
-        <a:srgbClr val="9C254D"/>
-      </a:accent3>
-      <a:accent4>
-        <a:srgbClr val="D23369"/>
-      </a:accent4>
-      <a:accent5>
-        <a:srgbClr val="F06292"/>
-      </a:accent5>
-      <a:accent6>
-        <a:srgbClr val="7890CD"/>
-      </a:accent6>
-      <a:hlink>
-        <a:srgbClr val="F06292"/>
-      </a:hlink>
-      <a:folHlink>
-        <a:srgbClr val="F06292"/>
-      </a:folHlink>
-    </a:clrScheme>
-    <a:fontScheme name="Office">
-      <a:majorFont>
-        <a:latin typeface="Arial"/>
-        <a:ea typeface=""/>
-        <a:cs typeface=""/>
-        <a:font script="Jpan" typeface="ＭＳ Ｐゴシック"/>
-        <a:font script="Hang" typeface="맑은 고딕"/>
-        <a:font script="Hans" typeface="宋体"/>
-        <a:font script="Hant" typeface="新細明體"/>
-        <a:font script="Arab" typeface="Times New Roman"/>
-        <a:font script="Hebr" typeface="Times New Roman"/>
-        <a:font script="Thai" typeface="Angsana New"/>
-        <a:font script="Ethi" typeface="Nyala"/>
-        <a:font script="Beng" typeface="Vrinda"/>
-        <a:font script="Gujr" typeface="Shruti"/>
-        <a:font script="Khmr" typeface="MoolBoran"/>
-        <a:font script="Knda" typeface="Tunga"/>
-        <a:font script="Guru" typeface="Raavi"/>
-        <a:font script="Cans" typeface="Euphemia"/>
-        <a:font script="Cher" typeface="Plantagenet Cherokee"/>
-        <a:font script="Yiii" typeface="Microsoft Yi Baiti"/>
-        <a:font script="Tibt" typeface="Microsoft Himalaya"/>
-        <a:font script="Thaa" typeface="MV Boli"/>
-        <a:font script="Deva" typeface="Mangal"/>
-        <a:font script="Telu" typeface="Gautami"/>
-        <a:font script="Taml" typeface="Latha"/>
-        <a:font script="Syrc" typeface="Estrangelo Edessa"/>
-        <a:font script="Orya" typeface="Kalinga"/>
-        <a:font script="Mlym" typeface="Kartika"/>
-        <a:font script="Laoo" typeface="DokChampa"/>
-        <a:font script="Sinh" typeface="Iskoola Pota"/>
-        <a:font script="Mong" typeface="Mongolian Baiti"/>
-        <a:font script="Viet" typeface="Times New Roman"/>
-        <a:font script="Uigh" typeface="Microsoft Uighur"/>
-        <a:font script="Geor" typeface="Sylfaen"/>
-      </a:majorFont>
-      <a:minorFont>
-        <a:latin typeface="Arial"/>
-        <a:ea typeface=""/>
-        <a:cs typeface=""/>
-        <a:font script="Jpan" typeface="ＭＳ Ｐゴシック"/>
-        <a:font script="Hang" typeface="맑은 고딕"/>
-        <a:font script="Hans" typeface="宋体"/>
-        <a:font script="Hant" typeface="新細明體"/>
-        <a:font script="Arab" typeface="Arial"/>
-        <a:font script="Hebr" typeface="Arial"/>
-        <a:font script="Thai" typeface="Cordia New"/>
-        <a:font script="Ethi" typeface="Nyala"/>
-        <a:font script="Beng" typeface="Vrinda"/>
-        <a:font script="Gujr" typeface="Shruti"/>
-        <a:font script="Khmr" typeface="DaunPenh"/>
-        <a:font script="Knda" typeface="Tunga"/>
-        <a:font script="Guru" typeface="Raavi"/>
-        <a:font script="Cans" typeface="Euphemia"/>
-        <a:font script="Cher" typeface="Plantagenet Cherokee"/>
-        <a:font script="Yiii" typeface="Microsoft Yi Baiti"/>
-        <a:font script="Tibt" typeface="Microsoft Himalaya"/>
-        <a:font script="Thaa" typeface="MV Boli"/>
-        <a:font script="Deva" typeface="Mangal"/>
-        <a:font script="Telu" typeface="Gautami"/>
-        <a:font script="Taml" typeface="Latha"/>
-        <a:font script="Syrc" typeface="Estrangelo Edessa"/>
-        <a:font script="Orya" typeface="Kalinga"/>
-        <a:font script="Mlym" typeface="Kartika"/>
-        <a:font script="Laoo" typeface="DokChampa"/>
-        <a:font script="Sinh" typeface="Iskoola Pota"/>
-        <a:font script="Mong" typeface="Mongolian Baiti"/>
-        <a:font script="Viet" typeface="Arial"/>
-        <a:font script="Uigh" typeface="Microsoft Uighur"/>
-        <a:font script="Geor" typeface="Sylfaen"/>
-      </a:minorFont>
-    </a:fontScheme>
-    <a:fmtScheme name="Office">
-      <a:fillStyleLst>
-        <a:solidFill>
-          <a:schemeClr val="phClr"/>
-        </a:solidFill>
-        <a:gradFill rotWithShape="1">
-          <a:gsLst>
-            <a:gs pos="0">
-              <a:schemeClr val="phClr">
-                <a:tint val="50000"/>
-                <a:satMod val="300000"/>
-              </a:schemeClr>
-            </a:gs>
-            <a:gs pos="35000">
-              <a:schemeClr val="phClr">
-                <a:tint val="37000"/>
-                <a:satMod val="300000"/>
-              </a:schemeClr>
-            </a:gs>
-            <a:gs pos="100000">
-              <a:schemeClr val="phClr">
-                <a:tint val="15000"/>
-                <a:satMod val="350000"/>
-              </a:schemeClr>
-            </a:gs>
-          </a:gsLst>
-          <a:lin ang="16200000" scaled="1"/>
-        </a:gradFill>
-        <a:gradFill rotWithShape="1">
-          <a:gsLst>
-            <a:gs pos="0">
-              <a:schemeClr val="phClr">
-                <a:tint val="100000"/>
-                <a:shade val="100000"/>
-                <a:satMod val="130000"/>
-              </a:schemeClr>
-            </a:gs>
-            <a:gs pos="100000">
-              <a:schemeClr val="phClr">
-                <a:tint val="50000"/>
-                <a:shade val="100000"/>
-                <a:satMod val="350000"/>
-              </a:schemeClr>
-            </a:gs>
-          </a:gsLst>
-          <a:lin ang="16200000" scaled="0"/>
-        </a:gradFill>
-      </a:fillStyleLst>
-      <a:lnStyleLst>
-        <a:ln w="9525" cap="flat" cmpd="sng" algn="ctr">
-          <a:solidFill>
-            <a:schemeClr val="phClr">
-              <a:shade val="95000"/>
-              <a:satMod val="105000"/>
-            </a:schemeClr>
-          </a:solidFill>
-          <a:prstDash val="solid"/>
-        </a:ln>
-        <a:ln w="25400" cap="flat" cmpd="sng" algn="ctr">
-          <a:solidFill>
-            <a:schemeClr val="phClr"/>
-          </a:solidFill>
-          <a:prstDash val="solid"/>
-        </a:ln>
-        <a:ln w="38100" cap="flat" cmpd="sng" algn="ctr">
-          <a:solidFill>
-            <a:schemeClr val="phClr"/>
-          </a:solidFill>
-          <a:prstDash val="solid"/>
-        </a:ln>
-      </a:lnStyleLst>
-      <a:effectStyleLst>
-        <a:effectStyle>
-          <a:effectLst>
-            <a:outerShdw blurRad="40000" dist="20000" dir="5400000" rotWithShape="0">
-              <a:srgbClr val="000000">
-                <a:alpha val="38000"/>
-              </a:srgbClr>
-            </a:outerShdw>
-          </a:effectLst>
-        </a:effectStyle>
-        <a:effectStyle>
-          <a:effectLst>
-            <a:outerShdw blurRad="40000" dist="23000" dir="5400000" rotWithShape="0">
-              <a:srgbClr val="000000">
-                <a:alpha val="35000"/>
-              </a:srgbClr>
-            </a:outerShdw>
-          </a:effectLst>
-        </a:effectStyle>
-        <a:effectStyle>
-          <a:effectLst>
-            <a:outerShdw blurRad="40000" dist="23000" dir="5400000" rotWithShape="0">
-              <a:srgbClr val="000000">
-                <a:alpha val="35000"/>
-              </a:srgbClr>
-            </a:outerShdw>
-          </a:effectLst>
-          <a:scene3d>
-            <a:camera prst="orthographicFront">
-              <a:rot lat="0" lon="0" rev="0"/>
-            </a:camera>
-            <a:lightRig rig="threePt" dir="t">
-              <a:rot lat="0" lon="0" rev="1200000"/>
-            </a:lightRig>
-          </a:scene3d>
-          <a:sp3d>
-            <a:bevelT w="63500" h="25400"/>
-          </a:sp3d>
-        </a:effectStyle>
-      </a:effectStyleLst>
-      <a:bgFillStyleLst>
-        <a:solidFill>
-          <a:schemeClr val="phClr"/>
-        </a:solidFill>
-        <a:gradFill rotWithShape="1">
-          <a:gsLst>
-            <a:gs pos="0">
-              <a:schemeClr val="phClr">
-                <a:tint val="40000"/>
-                <a:satMod val="350000"/>
-              </a:schemeClr>
-            </a:gs>
-            <a:gs pos="40000">
-              <a:schemeClr val="phClr">
-                <a:tint val="45000"/>
-                <a:shade val="99000"/>
-                <a:satMod val="350000"/>
-              </a:schemeClr>
-            </a:gs>
-            <a:gs pos="100000">
-              <a:schemeClr val="phClr">
-                <a:shade val="20000"/>
-                <a:satMod val="255000"/>
-              </a:schemeClr>
-            </a:gs>
-          </a:gsLst>
-          <a:path path="circle">
-            <a:fillToRect l="50000" t="-80000" r="50000" b="180000"/>
-          </a:path>
-        </a:gradFill>
-        <a:gradFill rotWithShape="1">
-          <a:gsLst>
-            <a:gs pos="0">
-              <a:schemeClr val="phClr">
-                <a:tint val="80000"/>
-                <a:satMod val="300000"/>
-              </a:schemeClr>
-            </a:gs>
-            <a:gs pos="100000">
-              <a:schemeClr val="phClr">
-                <a:shade val="30000"/>
-                <a:satMod val="200000"/>
-              </a:schemeClr>
-            </a:gs>
-          </a:gsLst>
-          <a:path path="circle">
-            <a:fillToRect l="50000" t="50000" r="50000" b="50000"/>
-          </a:path>
-        </a:gradFill>
-      </a:bgFillStyleLst>
-    </a:fmtScheme>
-  </a:themeElements>
-</a:theme>
 </file>
</xml_diff>